<commit_message>
Report the real-data evaluation and revise the paper
RQ7 (generated batches), RQ8 (real monthly batches) and RQ9 (real pandas
scripts, held-out set) were run again with one compiler binary after the last
fixes. RQ8: certificates admit 205 of 238 new months (the compiled month's own
facts 2), every admitted run equals a fresh compilation. RQ9: 1,347 of 1,364
runs on new batches are admitted and all reproduce the scripts' own results.
The first RQ9 run, which exposed a missing-column hole and a lifter bug, is kept
as pandas_corpus_firstrun.

The paper is reframed around data certificates (image boxes and their corners,
columns not read, optional columns, the pandas front end, RQ8, RQ9, and the
five bugs the evaluation found). NOVELTY.md gains a strict rating; the Review 3
report and presentation include the new results.
</commit_message>
<xml_diff>
--- a/docs/review3/PrepLang_Review3_Presentation.pptx
+++ b/docs/review3/PrepLang_Review3_Presentation.pptx
@@ -18,9 +18,10 @@
     <p:sldId id="266" r:id="rId12"/>
     <p:sldId id="267" r:id="rId13"/>
     <p:sldId id="268" r:id="rId14"/>
+    <p:sldId id="269" r:id="rId15"/>
   </p:sldIdLst>
   <p:notesMasterIdLst>
-    <p:notesMasterId r:id="rId15"/>
+    <p:notesMasterId r:id="rId16"/>
   </p:notesMasterIdLst>
   <p:sldSz cx="9144000" cy="5143500"/>
   <p:notesSz cx="5143500" cy="9144000"/>
@@ -119,13 +120,13 @@
   <p:extLst>
     <p:ext uri="{521415D9-36F7-43E2-AB2F-B90AF26B5E84}">
       <p14:sectionLst xmlns:p14="http://schemas.microsoft.com/office/powerpoint/2010/main">
-        <p14:section name="Introduction" id="{92eb9203-95fa-e541-ebee-be9cd84517e3}">
+        <p14:section name="Introduction" id="{d976c1ff-c4e5-abb5-cbe4-72ef9d200d93}">
           <p14:sldIdLst>
             <p14:sldId id="256"/>
             <p14:sldId id="257"/>
           </p14:sldIdLst>
         </p14:section>
-        <p14:section name="Design" id="{08a44d5c-d2bb-72cb-5ddc-ef5fd39397b2}">
+        <p14:section name="Design" id="{8d9bd3f8-0b8f-7d89-0d3f-0685ba455c42}">
           <p14:sldIdLst>
             <p14:sldId id="258"/>
             <p14:sldId id="259"/>
@@ -133,19 +134,20 @@
             <p14:sldId id="261"/>
           </p14:sldIdLst>
         </p14:section>
-        <p14:section name="New in Phase 3" id="{08d080c2-6016-7583-1895-bf313026666a}">
+        <p14:section name="New in Phase 3" id="{c66ac1cc-dbf9-0c62-fdfb-6d35311db38b}">
           <p14:sldIdLst>
             <p14:sldId id="262"/>
             <p14:sldId id="263"/>
             <p14:sldId id="264"/>
             <p14:sldId id="265"/>
+            <p14:sldId id="266"/>
           </p14:sldIdLst>
         </p14:section>
-        <p14:section name="Results" id="{4c26d5ad-7007-d408-5b5d-bf84ff257281}">
+        <p14:section name="Results" id="{0852f5a6-16e2-c20e-f8ef-16bd5c65ea90}">
           <p14:sldIdLst>
-            <p14:sldId id="266"/>
             <p14:sldId id="267"/>
             <p14:sldId id="268"/>
+            <p14:sldId id="269"/>
           </p14:sldIdLst>
         </p14:section>
       </p14:sectionLst>
@@ -1393,6 +1395,94 @@
             <a:fld id="{F7021451-1387-4CA6-816F-3879F97B5CBC}" type="slidenum">
               <a:rPr lang="en-US"/>
               <a:t>13</a:t>
+            </a:fld>
+            <a:endParaRPr lang="en-US"/>
+          </a:p>
+        </p:txBody>
+      </p:sp>
+    </p:spTree>
+    <p:extLst>
+      <p:ext uri="{BB962C8B-B14F-4D97-AF65-F5344CB8AC3E}">
+        <p14:creationId xmlns:p14="http://schemas.microsoft.com/office/powerpoint/2010/main" val="1024086991"/>
+      </p:ext>
+    </p:extLst>
+  </p:cSld>
+  <p:clrMapOvr>
+    <a:masterClrMapping/>
+  </p:clrMapOvr>
+</p:notes>
+</file>
+
+<file path=ppt/notesSlides/notesSlide14.xml><?xml version="1.0" encoding="utf-8"?>
+<p:notes xmlns:a="http://schemas.openxmlformats.org/drawingml/2006/main" xmlns:r="http://schemas.openxmlformats.org/officeDocument/2006/relationships" xmlns:p="http://schemas.openxmlformats.org/presentationml/2006/main">
+  <p:cSld>
+    <p:spTree>
+      <p:nvGrpSpPr>
+        <p:cNvPr id="1" name=""/>
+        <p:cNvGrpSpPr/>
+        <p:nvPr/>
+      </p:nvGrpSpPr>
+      <p:grpSpPr>
+        <a:xfrm>
+          <a:off x="0" y="0"/>
+          <a:ext cx="0" cy="0"/>
+          <a:chOff x="0" y="0"/>
+          <a:chExt cx="0" cy="0"/>
+        </a:xfrm>
+      </p:grpSpPr>
+      <p:sp>
+        <p:nvSpPr>
+          <p:cNvPr id="2" name="Slide Image Placeholder 1"/>
+          <p:cNvSpPr>
+            <a:spLocks noGrp="1" noRot="1" noChangeAspect="1"/>
+          </p:cNvSpPr>
+          <p:nvPr>
+            <p:ph type="sldImg"/>
+          </p:nvPr>
+        </p:nvSpPr>
+        <p:spPr/>
+      </p:sp>
+      <p:sp>
+        <p:nvSpPr>
+          <p:cNvPr id="3" name="Notes Placeholder 2"/>
+          <p:cNvSpPr>
+            <a:spLocks noGrp="1"/>
+          </p:cNvSpPr>
+          <p:nvPr>
+            <p:ph type="body" idx="1"/>
+          </p:nvPr>
+        </p:nvSpPr>
+        <p:spPr/>
+        <p:txBody>
+          <a:bodyPr/>
+          <a:lstStyle/>
+          <a:p>
+            <a:r>
+              <a:rPr lang="en-US" dirty="0"/>
+              <a:t/>
+            </a:r>
+            <a:endParaRPr lang="en-US" dirty="0"/>
+          </a:p>
+        </p:txBody>
+      </p:sp>
+      <p:sp>
+        <p:nvSpPr>
+          <p:cNvPr id="4" name="Slide Number Placeholder 3"/>
+          <p:cNvSpPr>
+            <a:spLocks noGrp="1"/>
+          </p:cNvSpPr>
+          <p:nvPr>
+            <p:ph type="sldNum" sz="quarter" idx="10"/>
+          </p:nvPr>
+        </p:nvSpPr>
+        <p:spPr/>
+        <p:txBody>
+          <a:bodyPr/>
+          <a:lstStyle/>
+          <a:p>
+            <a:fld id="{F7021451-1387-4CA6-816F-3879F97B5CBC}" type="slidenum">
+              <a:rPr lang="en-US"/>
+              <a:t>14</a:t>
             </a:fld>
             <a:endParaRPr lang="en-US"/>
           </a:p>
@@ -2706,38 +2796,205 @@
                 <a:ea typeface="Cambria" pitchFamily="34" charset="-122"/>
                 <a:cs typeface="Cambria" pitchFamily="34" charset="-120"/>
               </a:rPr>
-              <a:t>New: checking every cell beats a pandas read</a:t>
+              <a:t>Real data, real scripts: no unsound run</a:t>
             </a:r>
             <a:endParaRPr lang="en-US" sz="2800" dirty="0"/>
           </a:p>
         </p:txBody>
       </p:sp>
-      <p:graphicFrame>
-        <p:nvGraphicFramePr>
-          <p:cNvPr id="4" name="Chart 0" descr=""/>
-          <p:cNvGraphicFramePr/>
-          <p:nvPr/>
-        </p:nvGraphicFramePr>
-        <p:xfrm>
-          <a:off x="457200" y="1051560"/>
-          <a:ext cx="5120640" cy="3566160"/>
-        </p:xfrm>
-        <a:graphic xmlns:a="http://schemas.openxmlformats.org/drawingml/2006/main">
-          <a:graphicData uri="http://schemas.openxmlformats.org/drawingml/2006/chart">
-            <c:chart xmlns:c="http://schemas.openxmlformats.org/drawingml/2006/chart" r:id="rId1"/>
-          </a:graphicData>
-        </a:graphic>
-      </p:graphicFrame>
-      <p:sp>
-        <p:nvSpPr>
-          <p:cNvPr id="5" name="Text 2"/>
-          <p:cNvSpPr txBox="1"/>
-          <p:nvPr/>
-        </p:nvSpPr>
-        <p:spPr>
-          <a:xfrm>
-            <a:off x="5943600" y="1097280"/>
-            <a:ext cx="2743200" cy="365760"/>
+      <p:sp>
+        <p:nvSpPr>
+          <p:cNvPr id="4" name="Shape 2"/>
+          <p:cNvSpPr/>
+          <p:nvPr/>
+        </p:nvSpPr>
+        <p:spPr>
+          <a:xfrm>
+            <a:off x="457200" y="1097280"/>
+            <a:ext cx="4023360" cy="3291840"/>
+          </a:xfrm>
+          <a:prstGeom prst="roundRect">
+            <a:avLst>
+              <a:gd name="adj" fmla="val 2222"/>
+            </a:avLst>
+          </a:prstGeom>
+          <a:solidFill>
+            <a:srgbClr val="EEF1F4"/>
+          </a:solidFill>
+          <a:ln w="12700">
+            <a:solidFill>
+              <a:srgbClr val="EEF1F4"/>
+            </a:solidFill>
+            <a:prstDash val="solid"/>
+          </a:ln>
+        </p:spPr>
+      </p:sp>
+      <p:sp>
+        <p:nvSpPr>
+          <p:cNvPr id="5" name="Text 3"/>
+          <p:cNvSpPr txBox="1"/>
+          <p:nvPr/>
+        </p:nvSpPr>
+        <p:spPr>
+          <a:xfrm>
+            <a:off x="685800" y="1234440"/>
+            <a:ext cx="3657600" cy="365760"/>
+          </a:xfrm>
+          <a:prstGeom prst="rect">
+            <a:avLst/>
+          </a:prstGeom>
+          <a:noFill/>
+          <a:ln/>
+        </p:spPr>
+        <p:txBody>
+          <a:bodyPr wrap="square" lIns="0" tIns="0" rIns="0" bIns="0" rtlCol="0" anchor="ctr"/>
+          <a:lstStyle/>
+          <a:p>
+            <a:pPr indent="0" marL="0">
+              <a:buNone/>
+            </a:pPr>
+            <a:r>
+              <a:rPr lang="en-US" sz="1600" b="1" dirty="0">
+                <a:solidFill>
+                  <a:srgbClr val="23867A"/>
+                </a:solidFill>
+                <a:latin typeface="Calibri" pitchFamily="34" charset="0"/>
+                <a:ea typeface="Calibri" pitchFamily="34" charset="-122"/>
+                <a:cs typeface="Calibri" pitchFamily="34" charset="-120"/>
+              </a:rPr>
+              <a:t>Real monthly data</a:t>
+            </a:r>
+            <a:endParaRPr lang="en-US" sz="1600" dirty="0"/>
+          </a:p>
+        </p:txBody>
+      </p:sp>
+      <p:sp>
+        <p:nvSpPr>
+          <p:cNvPr id="6" name="Text 4"/>
+          <p:cNvSpPr txBox="1"/>
+          <p:nvPr/>
+        </p:nvSpPr>
+        <p:spPr>
+          <a:xfrm>
+            <a:off x="685800" y="1600200"/>
+            <a:ext cx="3657600" cy="548640"/>
+          </a:xfrm>
+          <a:prstGeom prst="rect">
+            <a:avLst/>
+          </a:prstGeom>
+          <a:noFill/>
+          <a:ln/>
+        </p:spPr>
+        <p:txBody>
+          <a:bodyPr wrap="square" lIns="0" tIns="0" rIns="0" bIns="0" rtlCol="0" anchor="ctr"/>
+          <a:lstStyle/>
+          <a:p>
+            <a:pPr indent="0" marL="0">
+              <a:buNone/>
+            </a:pPr>
+            <a:r>
+              <a:rPr lang="en-US" sz="1200" dirty="0">
+                <a:solidFill>
+                  <a:srgbClr val="5B6573"/>
+                </a:solidFill>
+                <a:latin typeface="Calibri" pitchFamily="34" charset="0"/>
+                <a:ea typeface="Calibri" pitchFamily="34" charset="-122"/>
+                <a:cs typeface="Calibri" pitchFamily="34" charset="-120"/>
+              </a:rPr>
+              <a:t>Traffic sensors and bike rentals (UCI), New York green taxi Parquet files 2022-2024</a:t>
+            </a:r>
+            <a:endParaRPr lang="en-US" sz="1200" dirty="0"/>
+          </a:p>
+        </p:txBody>
+      </p:sp>
+      <p:sp>
+        <p:nvSpPr>
+          <p:cNvPr id="7" name="Text 5"/>
+          <p:cNvSpPr txBox="1"/>
+          <p:nvPr/>
+        </p:nvSpPr>
+        <p:spPr>
+          <a:xfrm>
+            <a:off x="685800" y="2194560"/>
+            <a:ext cx="3657600" cy="685800"/>
+          </a:xfrm>
+          <a:prstGeom prst="rect">
+            <a:avLst/>
+          </a:prstGeom>
+          <a:noFill/>
+          <a:ln/>
+        </p:spPr>
+        <p:txBody>
+          <a:bodyPr wrap="square" lIns="0" tIns="0" rIns="0" bIns="0" rtlCol="0" anchor="ctr"/>
+          <a:lstStyle/>
+          <a:p>
+            <a:pPr indent="0" marL="0">
+              <a:buNone/>
+            </a:pPr>
+            <a:r>
+              <a:rPr lang="en-US" sz="4000" b="1" dirty="0">
+                <a:solidFill>
+                  <a:srgbClr val="1B2430"/>
+                </a:solidFill>
+                <a:latin typeface="Cambria" pitchFamily="34" charset="0"/>
+                <a:ea typeface="Cambria" pitchFamily="34" charset="-122"/>
+                <a:cs typeface="Cambria" pitchFamily="34" charset="-120"/>
+              </a:rPr>
+              <a:t>86%</a:t>
+            </a:r>
+            <a:endParaRPr lang="en-US" sz="4000" dirty="0"/>
+          </a:p>
+        </p:txBody>
+      </p:sp>
+      <p:sp>
+        <p:nvSpPr>
+          <p:cNvPr id="8" name="Text 6"/>
+          <p:cNvSpPr txBox="1"/>
+          <p:nvPr/>
+        </p:nvSpPr>
+        <p:spPr>
+          <a:xfrm>
+            <a:off x="685800" y="2880360"/>
+            <a:ext cx="3657600" cy="502920"/>
+          </a:xfrm>
+          <a:prstGeom prst="rect">
+            <a:avLst/>
+          </a:prstGeom>
+          <a:noFill/>
+          <a:ln/>
+        </p:spPr>
+        <p:txBody>
+          <a:bodyPr wrap="square" lIns="0" tIns="0" rIns="0" bIns="0" rtlCol="0" anchor="ctr"/>
+          <a:lstStyle/>
+          <a:p>
+            <a:pPr indent="0" marL="0">
+              <a:buNone/>
+            </a:pPr>
+            <a:r>
+              <a:rPr lang="en-US" sz="1300" dirty="0">
+                <a:solidFill>
+                  <a:srgbClr val="5B6573"/>
+                </a:solidFill>
+                <a:latin typeface="Calibri" pitchFamily="34" charset="0"/>
+                <a:ea typeface="Calibri" pitchFamily="34" charset="-122"/>
+                <a:cs typeface="Calibri" pitchFamily="34" charset="-120"/>
+              </a:rPr>
+              <a:t>of 238 new months admitted; the month's own facts: 1%</a:t>
+            </a:r>
+            <a:endParaRPr lang="en-US" sz="1300" dirty="0"/>
+          </a:p>
+        </p:txBody>
+      </p:sp>
+      <p:sp>
+        <p:nvSpPr>
+          <p:cNvPr id="9" name="Text 7"/>
+          <p:cNvSpPr txBox="1"/>
+          <p:nvPr/>
+        </p:nvSpPr>
+        <p:spPr>
+          <a:xfrm>
+            <a:off x="685800" y="3566160"/>
+            <a:ext cx="3657600" cy="548640"/>
           </a:xfrm>
           <a:prstGeom prst="rect">
             <a:avLst/>
@@ -2761,7 +3018,7 @@
                 <a:ea typeface="Calibri" pitchFamily="34" charset="-122"/>
                 <a:cs typeface="Calibri" pitchFamily="34" charset="-120"/>
               </a:rPr>
-              <a:t>One million CSV rows x 10 columns</a:t>
+              <a:t>0 admitted runs differ from a fresh compilation</a:t>
             </a:r>
             <a:endParaRPr lang="en-US" sz="1300" dirty="0"/>
           </a:p>
@@ -2769,105 +3026,221 @@
       </p:sp>
       <p:sp>
         <p:nvSpPr>
-          <p:cNvPr id="6" name="Text 3"/>
-          <p:cNvSpPr txBox="1"/>
-          <p:nvPr/>
-        </p:nvSpPr>
-        <p:spPr>
-          <a:xfrm>
-            <a:off x="5943600" y="1554480"/>
-            <a:ext cx="2743200" cy="3017520"/>
-          </a:xfrm>
-          <a:prstGeom prst="rect">
-            <a:avLst/>
-          </a:prstGeom>
-          <a:noFill/>
-          <a:ln/>
-        </p:spPr>
-        <p:txBody>
-          <a:bodyPr wrap="square" lIns="0" tIns="0" rIns="0" bIns="0" rtlCol="0" anchor="t"/>
-          <a:lstStyle/>
-          <a:p>
-            <a:pPr marL="342900" indent="-342900">
-              <a:spcAft>
-                <a:spcPts val="600"/>
-              </a:spcAft>
-              <a:buSzPct val="100000"/>
-              <a:buChar char="•"/>
+          <p:cNvPr id="10" name="Shape 8"/>
+          <p:cNvSpPr/>
+          <p:nvPr/>
+        </p:nvSpPr>
+        <p:spPr>
+          <a:xfrm>
+            <a:off x="4663440" y="1097280"/>
+            <a:ext cx="4023360" cy="3291840"/>
+          </a:xfrm>
+          <a:prstGeom prst="roundRect">
+            <a:avLst>
+              <a:gd name="adj" fmla="val 2222"/>
+            </a:avLst>
+          </a:prstGeom>
+          <a:solidFill>
+            <a:srgbClr val="EEF1F4"/>
+          </a:solidFill>
+          <a:ln w="12700">
+            <a:solidFill>
+              <a:srgbClr val="EEF1F4"/>
+            </a:solidFill>
+            <a:prstDash val="solid"/>
+          </a:ln>
+        </p:spPr>
+      </p:sp>
+      <p:sp>
+        <p:nvSpPr>
+          <p:cNvPr id="11" name="Text 9"/>
+          <p:cNvSpPr txBox="1"/>
+          <p:nvPr/>
+        </p:nvSpPr>
+        <p:spPr>
+          <a:xfrm>
+            <a:off x="4892040" y="1234440"/>
+            <a:ext cx="3657600" cy="365760"/>
+          </a:xfrm>
+          <a:prstGeom prst="rect">
+            <a:avLst/>
+          </a:prstGeom>
+          <a:noFill/>
+          <a:ln/>
+        </p:spPr>
+        <p:txBody>
+          <a:bodyPr wrap="square" lIns="0" tIns="0" rIns="0" bIns="0" rtlCol="0" anchor="ctr"/>
+          <a:lstStyle/>
+          <a:p>
+            <a:pPr indent="0" marL="0">
+              <a:buNone/>
+            </a:pPr>
+            <a:r>
+              <a:rPr lang="en-US" sz="1600" b="1" dirty="0">
+                <a:solidFill>
+                  <a:srgbClr val="23867A"/>
+                </a:solidFill>
+                <a:latin typeface="Calibri" pitchFamily="34" charset="0"/>
+                <a:ea typeface="Calibri" pitchFamily="34" charset="-122"/>
+                <a:cs typeface="Calibri" pitchFamily="34" charset="-120"/>
+              </a:rPr>
+              <a:t>Real pandas scripts</a:t>
+            </a:r>
+            <a:endParaRPr lang="en-US" sz="1600" dirty="0"/>
+          </a:p>
+        </p:txBody>
+      </p:sp>
+      <p:sp>
+        <p:nvSpPr>
+          <p:cNvPr id="12" name="Text 10"/>
+          <p:cNvSpPr txBox="1"/>
+          <p:nvPr/>
+        </p:nvSpPr>
+        <p:spPr>
+          <a:xfrm>
+            <a:off x="4892040" y="1600200"/>
+            <a:ext cx="3657600" cy="548640"/>
+          </a:xfrm>
+          <a:prstGeom prst="rect">
+            <a:avLst/>
+          </a:prstGeom>
+          <a:noFill/>
+          <a:ln/>
+        </p:spPr>
+        <p:txBody>
+          <a:bodyPr wrap="square" lIns="0" tIns="0" rIns="0" bIns="0" rtlCol="0" anchor="ctr"/>
+          <a:lstStyle/>
+          <a:p>
+            <a:pPr indent="0" marL="0">
+              <a:buNone/>
+            </a:pPr>
+            <a:r>
+              <a:rPr lang="en-US" sz="1200" dirty="0">
+                <a:solidFill>
+                  <a:srgbClr val="5B6573"/>
+                </a:solidFill>
+                <a:latin typeface="Calibri" pitchFamily="34" charset="0"/>
+                <a:ea typeface="Calibri" pitchFamily="34" charset="-122"/>
+                <a:cs typeface="Calibri" pitchFamily="34" charset="-120"/>
+              </a:rPr>
+              <a:t>372 Titanic scripts from GitHub; 124 held-out scripts lifted into PrepLang by a new front end</a:t>
+            </a:r>
+            <a:endParaRPr lang="en-US" sz="1200" dirty="0"/>
+          </a:p>
+        </p:txBody>
+      </p:sp>
+      <p:sp>
+        <p:nvSpPr>
+          <p:cNvPr id="13" name="Text 11"/>
+          <p:cNvSpPr txBox="1"/>
+          <p:nvPr/>
+        </p:nvSpPr>
+        <p:spPr>
+          <a:xfrm>
+            <a:off x="4892040" y="2194560"/>
+            <a:ext cx="3657600" cy="685800"/>
+          </a:xfrm>
+          <a:prstGeom prst="rect">
+            <a:avLst/>
+          </a:prstGeom>
+          <a:noFill/>
+          <a:ln/>
+        </p:spPr>
+        <p:txBody>
+          <a:bodyPr wrap="square" lIns="0" tIns="0" rIns="0" bIns="0" rtlCol="0" anchor="ctr"/>
+          <a:lstStyle/>
+          <a:p>
+            <a:pPr indent="0" marL="0">
+              <a:buNone/>
+            </a:pPr>
+            <a:r>
+              <a:rPr lang="en-US" sz="4000" b="1" dirty="0">
+                <a:solidFill>
+                  <a:srgbClr val="1B2430"/>
+                </a:solidFill>
+                <a:latin typeface="Cambria" pitchFamily="34" charset="0"/>
+                <a:ea typeface="Cambria" pitchFamily="34" charset="-122"/>
+                <a:cs typeface="Cambria" pitchFamily="34" charset="-120"/>
+              </a:rPr>
+              <a:t>1347</a:t>
+            </a:r>
+            <a:endParaRPr lang="en-US" sz="4000" dirty="0"/>
+          </a:p>
+        </p:txBody>
+      </p:sp>
+      <p:sp>
+        <p:nvSpPr>
+          <p:cNvPr id="14" name="Text 12"/>
+          <p:cNvSpPr txBox="1"/>
+          <p:nvPr/>
+        </p:nvSpPr>
+        <p:spPr>
+          <a:xfrm>
+            <a:off x="4892040" y="2880360"/>
+            <a:ext cx="3657600" cy="502920"/>
+          </a:xfrm>
+          <a:prstGeom prst="rect">
+            <a:avLst/>
+          </a:prstGeom>
+          <a:noFill/>
+          <a:ln/>
+        </p:spPr>
+        <p:txBody>
+          <a:bodyPr wrap="square" lIns="0" tIns="0" rIns="0" bIns="0" rtlCol="0" anchor="ctr"/>
+          <a:lstStyle/>
+          <a:p>
+            <a:pPr indent="0" marL="0">
+              <a:buNone/>
             </a:pPr>
             <a:r>
               <a:rPr lang="en-US" sz="1300" dirty="0">
                 <a:solidFill>
+                  <a:srgbClr val="5B6573"/>
+                </a:solidFill>
+                <a:latin typeface="Calibri" pitchFamily="34" charset="0"/>
+                <a:ea typeface="Calibri" pitchFamily="34" charset="-122"/>
+                <a:cs typeface="Calibri" pitchFamily="34" charset="-120"/>
+              </a:rPr>
+              <a:t>of 1364 runs on new batches give exactly the script's own result</a:t>
+            </a:r>
+            <a:endParaRPr lang="en-US" sz="1300" dirty="0"/>
+          </a:p>
+        </p:txBody>
+      </p:sp>
+      <p:sp>
+        <p:nvSpPr>
+          <p:cNvPr id="15" name="Text 13"/>
+          <p:cNvSpPr txBox="1"/>
+          <p:nvPr/>
+        </p:nvSpPr>
+        <p:spPr>
+          <a:xfrm>
+            <a:off x="4892040" y="3566160"/>
+            <a:ext cx="3657600" cy="548640"/>
+          </a:xfrm>
+          <a:prstGeom prst="rect">
+            <a:avLst/>
+          </a:prstGeom>
+          <a:noFill/>
+          <a:ln/>
+        </p:spPr>
+        <p:txBody>
+          <a:bodyPr wrap="square" lIns="0" tIns="0" rIns="0" bIns="0" rtlCol="0" anchor="ctr"/>
+          <a:lstStyle/>
+          <a:p>
+            <a:pPr indent="0" marL="0">
+              <a:buNone/>
+            </a:pPr>
+            <a:r>
+              <a:rPr lang="en-US" sz="1300" b="1" dirty="0">
+                <a:solidFill>
                   <a:srgbClr val="1B2430"/>
                 </a:solidFill>
                 <a:latin typeface="Calibri" pitchFamily="34" charset="0"/>
                 <a:ea typeface="Calibri" pitchFamily="34" charset="-122"/>
                 <a:cs typeface="Calibri" pitchFamily="34" charset="-120"/>
               </a:rPr>
-              <a:t>One read, one piece per core, cut at line breaks</a:t>
-            </a:r>
-            <a:endParaRPr lang="en-US" sz="1300" dirty="0"/>
-          </a:p>
-          <a:p>
-            <a:pPr marL="342900" indent="-342900">
-              <a:spcAft>
-                <a:spcPts val="600"/>
-              </a:spcAft>
-              <a:buSzPct val="100000"/>
-              <a:buChar char="•"/>
-            </a:pPr>
-            <a:r>
-              <a:rPr lang="en-US" sz="1300" dirty="0">
-                <a:solidFill>
-                  <a:srgbClr val="1B2430"/>
-                </a:solidFill>
-                <a:latin typeface="Calibri" pitchFamily="34" charset="0"/>
-                <a:ea typeface="Calibri" pitchFamily="34" charset="-122"/>
-                <a:cs typeface="Calibri" pitchFamily="34" charset="-120"/>
-              </a:rPr>
-              <a:t>Cells viewed in place (string_view), no copies</a:t>
-            </a:r>
-            <a:endParaRPr lang="en-US" sz="1300" dirty="0"/>
-          </a:p>
-          <a:p>
-            <a:pPr marL="342900" indent="-342900">
-              <a:spcAft>
-                <a:spcPts val="600"/>
-              </a:spcAft>
-              <a:buSzPct val="100000"/>
-              <a:buChar char="•"/>
-            </a:pPr>
-            <a:r>
-              <a:rPr lang="en-US" sz="1300" dirty="0">
-                <a:solidFill>
-                  <a:srgbClr val="1B2430"/>
-                </a:solidFill>
-                <a:latin typeface="Calibri" pitchFamily="34" charset="0"/>
-                <a:ea typeface="Calibri" pitchFamily="34" charset="-122"/>
-                <a:cs typeface="Calibri" pitchFamily="34" charset="-120"/>
-              </a:rPr>
-              <a:t>Numbers parsed exactly in one pass (Clinger's fast path)</a:t>
-            </a:r>
-            <a:endParaRPr lang="en-US" sz="1300" dirty="0"/>
-          </a:p>
-          <a:p>
-            <a:pPr marL="342900" indent="-342900">
-              <a:spcAft>
-                <a:spcPts val="600"/>
-              </a:spcAft>
-              <a:buSzPct val="100000"/>
-              <a:buChar char="•"/>
-            </a:pPr>
-            <a:r>
-              <a:rPr lang="en-US" sz="1300" dirty="0">
-                <a:solidFill>
-                  <a:srgbClr val="1B2430"/>
-                </a:solidFill>
-                <a:latin typeface="Calibri" pitchFamily="34" charset="0"/>
-                <a:ea typeface="Calibri" pitchFamily="34" charset="-122"/>
-                <a:cs typeface="Calibri" pitchFamily="34" charset="-120"/>
-              </a:rPr>
-              <a:t>CRC-32 on its own thread; merge in file order gives the same facts and line numbers</a:t>
+              <a:t>0 admitted runs differ from the script</a:t>
             </a:r>
             <a:endParaRPr lang="en-US" sz="1300" dirty="0"/>
           </a:p>
@@ -2977,427 +3350,168 @@
                 <a:ea typeface="Cambria" pitchFamily="34" charset="-122"/>
                 <a:cs typeface="Cambria" pitchFamily="34" charset="-120"/>
               </a:rPr>
-              <a:t>Testing and evaluation</a:t>
+              <a:t>New: checking every cell beats a pandas read</a:t>
             </a:r>
             <a:endParaRPr lang="en-US" sz="2800" dirty="0"/>
           </a:p>
         </p:txBody>
       </p:sp>
-      <p:sp>
-        <p:nvSpPr>
-          <p:cNvPr id="4" name="Shape 2"/>
-          <p:cNvSpPr/>
-          <p:nvPr/>
-        </p:nvSpPr>
-        <p:spPr>
-          <a:xfrm>
-            <a:off x="457200" y="1097280"/>
-            <a:ext cx="4023360" cy="1463040"/>
-          </a:xfrm>
-          <a:prstGeom prst="roundRect">
-            <a:avLst>
-              <a:gd name="adj" fmla="val 5000"/>
-            </a:avLst>
-          </a:prstGeom>
-          <a:solidFill>
-            <a:srgbClr val="EEF1F4"/>
-          </a:solidFill>
-          <a:ln w="12700">
-            <a:solidFill>
-              <a:srgbClr val="EEF1F4"/>
-            </a:solidFill>
-            <a:prstDash val="solid"/>
-          </a:ln>
-        </p:spPr>
-      </p:sp>
-      <p:sp>
-        <p:nvSpPr>
-          <p:cNvPr id="5" name="Text 3"/>
-          <p:cNvSpPr txBox="1"/>
-          <p:nvPr/>
-        </p:nvSpPr>
-        <p:spPr>
-          <a:xfrm>
-            <a:off x="685800" y="1188720"/>
-            <a:ext cx="3566160" cy="685800"/>
-          </a:xfrm>
-          <a:prstGeom prst="rect">
-            <a:avLst/>
-          </a:prstGeom>
-          <a:noFill/>
-          <a:ln/>
-        </p:spPr>
-        <p:txBody>
-          <a:bodyPr wrap="square" lIns="0" tIns="0" rIns="0" bIns="0" rtlCol="0" anchor="ctr"/>
-          <a:lstStyle/>
-          <a:p>
-            <a:pPr indent="0" marL="0">
-              <a:buNone/>
-            </a:pPr>
-            <a:r>
-              <a:rPr lang="en-US" sz="4000" b="1" dirty="0">
+      <p:graphicFrame>
+        <p:nvGraphicFramePr>
+          <p:cNvPr id="4" name="Chart 0" descr=""/>
+          <p:cNvGraphicFramePr/>
+          <p:nvPr/>
+        </p:nvGraphicFramePr>
+        <p:xfrm>
+          <a:off x="457200" y="1051560"/>
+          <a:ext cx="5120640" cy="3566160"/>
+        </p:xfrm>
+        <a:graphic xmlns:a="http://schemas.openxmlformats.org/drawingml/2006/main">
+          <a:graphicData uri="http://schemas.openxmlformats.org/drawingml/2006/chart">
+            <c:chart xmlns:c="http://schemas.openxmlformats.org/drawingml/2006/chart" r:id="rId1"/>
+          </a:graphicData>
+        </a:graphic>
+      </p:graphicFrame>
+      <p:sp>
+        <p:nvSpPr>
+          <p:cNvPr id="5" name="Text 2"/>
+          <p:cNvSpPr txBox="1"/>
+          <p:nvPr/>
+        </p:nvSpPr>
+        <p:spPr>
+          <a:xfrm>
+            <a:off x="5943600" y="1097280"/>
+            <a:ext cx="2743200" cy="365760"/>
+          </a:xfrm>
+          <a:prstGeom prst="rect">
+            <a:avLst/>
+          </a:prstGeom>
+          <a:noFill/>
+          <a:ln/>
+        </p:spPr>
+        <p:txBody>
+          <a:bodyPr wrap="square" lIns="0" tIns="0" rIns="0" bIns="0" rtlCol="0" anchor="ctr"/>
+          <a:lstStyle/>
+          <a:p>
+            <a:pPr indent="0" marL="0">
+              <a:buNone/>
+            </a:pPr>
+            <a:r>
+              <a:rPr lang="en-US" sz="1300" b="1" dirty="0">
                 <a:solidFill>
                   <a:srgbClr val="1B2430"/>
                 </a:solidFill>
-                <a:latin typeface="Cambria" pitchFamily="34" charset="0"/>
-                <a:ea typeface="Cambria" pitchFamily="34" charset="-122"/>
-                <a:cs typeface="Cambria" pitchFamily="34" charset="-120"/>
-              </a:rPr>
-              <a:t>181</a:t>
-            </a:r>
-            <a:endParaRPr lang="en-US" sz="4000" dirty="0"/>
-          </a:p>
-        </p:txBody>
-      </p:sp>
-      <p:sp>
-        <p:nvSpPr>
-          <p:cNvPr id="6" name="Text 4"/>
-          <p:cNvSpPr txBox="1"/>
-          <p:nvPr/>
-        </p:nvSpPr>
-        <p:spPr>
-          <a:xfrm>
-            <a:off x="685800" y="1874520"/>
-            <a:ext cx="3566160" cy="502920"/>
-          </a:xfrm>
-          <a:prstGeom prst="rect">
-            <a:avLst/>
-          </a:prstGeom>
-          <a:noFill/>
-          <a:ln/>
-        </p:spPr>
-        <p:txBody>
-          <a:bodyPr wrap="square" lIns="0" tIns="0" rIns="0" bIns="0" rtlCol="0" anchor="ctr"/>
-          <a:lstStyle/>
-          <a:p>
-            <a:pPr indent="0" marL="0">
-              <a:buNone/>
+                <a:latin typeface="Calibri" pitchFamily="34" charset="0"/>
+                <a:ea typeface="Calibri" pitchFamily="34" charset="-122"/>
+                <a:cs typeface="Calibri" pitchFamily="34" charset="-120"/>
+              </a:rPr>
+              <a:t>One million CSV rows x 10 columns</a:t>
+            </a:r>
+            <a:endParaRPr lang="en-US" sz="1300" dirty="0"/>
+          </a:p>
+        </p:txBody>
+      </p:sp>
+      <p:sp>
+        <p:nvSpPr>
+          <p:cNvPr id="6" name="Text 3"/>
+          <p:cNvSpPr txBox="1"/>
+          <p:nvPr/>
+        </p:nvSpPr>
+        <p:spPr>
+          <a:xfrm>
+            <a:off x="5943600" y="1554480"/>
+            <a:ext cx="2743200" cy="3017520"/>
+          </a:xfrm>
+          <a:prstGeom prst="rect">
+            <a:avLst/>
+          </a:prstGeom>
+          <a:noFill/>
+          <a:ln/>
+        </p:spPr>
+        <p:txBody>
+          <a:bodyPr wrap="square" lIns="0" tIns="0" rIns="0" bIns="0" rtlCol="0" anchor="t"/>
+          <a:lstStyle/>
+          <a:p>
+            <a:pPr marL="342900" indent="-342900">
+              <a:spcAft>
+                <a:spcPts val="600"/>
+              </a:spcAft>
+              <a:buSzPct val="100000"/>
+              <a:buChar char="•"/>
             </a:pPr>
             <a:r>
               <a:rPr lang="en-US" sz="1300" dirty="0">
                 <a:solidFill>
-                  <a:srgbClr val="5B6573"/>
-                </a:solidFill>
-                <a:latin typeface="Calibri" pitchFamily="34" charset="0"/>
-                <a:ea typeface="Calibri" pitchFamily="34" charset="-122"/>
-                <a:cs typeface="Calibri" pitchFamily="34" charset="-120"/>
-              </a:rPr>
-              <a:t>unit tests in 9 programs, all passing</a:t>
+                  <a:srgbClr val="1B2430"/>
+                </a:solidFill>
+                <a:latin typeface="Calibri" pitchFamily="34" charset="0"/>
+                <a:ea typeface="Calibri" pitchFamily="34" charset="-122"/>
+                <a:cs typeface="Calibri" pitchFamily="34" charset="-120"/>
+              </a:rPr>
+              <a:t>One read, one piece per core, cut at line breaks</a:t>
             </a:r>
             <a:endParaRPr lang="en-US" sz="1300" dirty="0"/>
           </a:p>
-        </p:txBody>
-      </p:sp>
-      <p:sp>
-        <p:nvSpPr>
-          <p:cNvPr id="7" name="Shape 5"/>
-          <p:cNvSpPr/>
-          <p:nvPr/>
-        </p:nvSpPr>
-        <p:spPr>
-          <a:xfrm>
-            <a:off x="4663440" y="1097280"/>
-            <a:ext cx="4023360" cy="1463040"/>
-          </a:xfrm>
-          <a:prstGeom prst="roundRect">
-            <a:avLst>
-              <a:gd name="adj" fmla="val 5000"/>
-            </a:avLst>
-          </a:prstGeom>
-          <a:solidFill>
-            <a:srgbClr val="EEF1F4"/>
-          </a:solidFill>
-          <a:ln w="12700">
-            <a:solidFill>
-              <a:srgbClr val="EEF1F4"/>
-            </a:solidFill>
-            <a:prstDash val="solid"/>
-          </a:ln>
-        </p:spPr>
-      </p:sp>
-      <p:sp>
-        <p:nvSpPr>
-          <p:cNvPr id="8" name="Text 6"/>
-          <p:cNvSpPr txBox="1"/>
-          <p:nvPr/>
-        </p:nvSpPr>
-        <p:spPr>
-          <a:xfrm>
-            <a:off x="4892040" y="1188720"/>
-            <a:ext cx="3566160" cy="685800"/>
-          </a:xfrm>
-          <a:prstGeom prst="rect">
-            <a:avLst/>
-          </a:prstGeom>
-          <a:noFill/>
-          <a:ln/>
-        </p:spPr>
-        <p:txBody>
-          <a:bodyPr wrap="square" lIns="0" tIns="0" rIns="0" bIns="0" rtlCol="0" anchor="ctr"/>
-          <a:lstStyle/>
-          <a:p>
-            <a:pPr indent="0" marL="0">
-              <a:buNone/>
-            </a:pPr>
-            <a:r>
-              <a:rPr lang="en-US" sz="4000" b="1" dirty="0">
-                <a:solidFill>
-                  <a:srgbClr val="23867A"/>
-                </a:solidFill>
-                <a:latin typeface="Cambria" pitchFamily="34" charset="0"/>
-                <a:ea typeface="Cambria" pitchFamily="34" charset="-122"/>
-                <a:cs typeface="Cambria" pitchFamily="34" charset="-120"/>
-              </a:rPr>
-              <a:t>17</a:t>
-            </a:r>
-            <a:endParaRPr lang="en-US" sz="4000" dirty="0"/>
-          </a:p>
-        </p:txBody>
-      </p:sp>
-      <p:sp>
-        <p:nvSpPr>
-          <p:cNvPr id="9" name="Text 7"/>
-          <p:cNvSpPr txBox="1"/>
-          <p:nvPr/>
-        </p:nvSpPr>
-        <p:spPr>
-          <a:xfrm>
-            <a:off x="4892040" y="1874520"/>
-            <a:ext cx="3566160" cy="502920"/>
-          </a:xfrm>
-          <a:prstGeom prst="rect">
-            <a:avLst/>
-          </a:prstGeom>
-          <a:noFill/>
-          <a:ln/>
-        </p:spPr>
-        <p:txBody>
-          <a:bodyPr wrap="square" lIns="0" tIns="0" rIns="0" bIns="0" rtlCol="0" anchor="ctr"/>
-          <a:lstStyle/>
-          <a:p>
-            <a:pPr indent="0" marL="0">
-              <a:buNone/>
+          <a:p>
+            <a:pPr marL="342900" indent="-342900">
+              <a:spcAft>
+                <a:spcPts val="600"/>
+              </a:spcAft>
+              <a:buSzPct val="100000"/>
+              <a:buChar char="•"/>
             </a:pPr>
             <a:r>
               <a:rPr lang="en-US" sz="1300" dirty="0">
                 <a:solidFill>
-                  <a:srgbClr val="5B6573"/>
-                </a:solidFill>
-                <a:latin typeface="Calibri" pitchFamily="34" charset="0"/>
-                <a:ea typeface="Calibri" pitchFamily="34" charset="-122"/>
-                <a:cs typeface="Calibri" pitchFamily="34" charset="-120"/>
-              </a:rPr>
-              <a:t>recorded test cases: valid, invalid, boundary, run time</a:t>
+                  <a:srgbClr val="1B2430"/>
+                </a:solidFill>
+                <a:latin typeface="Calibri" pitchFamily="34" charset="0"/>
+                <a:ea typeface="Calibri" pitchFamily="34" charset="-122"/>
+                <a:cs typeface="Calibri" pitchFamily="34" charset="-120"/>
+              </a:rPr>
+              <a:t>Cells viewed in place (string_view), no copies</a:t>
             </a:r>
             <a:endParaRPr lang="en-US" sz="1300" dirty="0"/>
           </a:p>
-        </p:txBody>
-      </p:sp>
-      <p:sp>
-        <p:nvSpPr>
-          <p:cNvPr id="10" name="Shape 8"/>
-          <p:cNvSpPr/>
-          <p:nvPr/>
-        </p:nvSpPr>
-        <p:spPr>
-          <a:xfrm>
-            <a:off x="457200" y="2788920"/>
-            <a:ext cx="4023360" cy="1463040"/>
-          </a:xfrm>
-          <a:prstGeom prst="roundRect">
-            <a:avLst>
-              <a:gd name="adj" fmla="val 5000"/>
-            </a:avLst>
-          </a:prstGeom>
-          <a:solidFill>
-            <a:srgbClr val="EEF1F4"/>
-          </a:solidFill>
-          <a:ln w="12700">
-            <a:solidFill>
-              <a:srgbClr val="EEF1F4"/>
-            </a:solidFill>
-            <a:prstDash val="solid"/>
-          </a:ln>
-        </p:spPr>
-      </p:sp>
-      <p:sp>
-        <p:nvSpPr>
-          <p:cNvPr id="11" name="Text 9"/>
-          <p:cNvSpPr txBox="1"/>
-          <p:nvPr/>
-        </p:nvSpPr>
-        <p:spPr>
-          <a:xfrm>
-            <a:off x="685800" y="2880360"/>
-            <a:ext cx="3566160" cy="685800"/>
-          </a:xfrm>
-          <a:prstGeom prst="rect">
-            <a:avLst/>
-          </a:prstGeom>
-          <a:noFill/>
-          <a:ln/>
-        </p:spPr>
-        <p:txBody>
-          <a:bodyPr wrap="square" lIns="0" tIns="0" rIns="0" bIns="0" rtlCol="0" anchor="ctr"/>
-          <a:lstStyle/>
-          <a:p>
-            <a:pPr indent="0" marL="0">
-              <a:buNone/>
-            </a:pPr>
-            <a:r>
-              <a:rPr lang="en-US" sz="4000" b="1" dirty="0">
+          <a:p>
+            <a:pPr marL="342900" indent="-342900">
+              <a:spcAft>
+                <a:spcPts val="600"/>
+              </a:spcAft>
+              <a:buSzPct val="100000"/>
+              <a:buChar char="•"/>
+            </a:pPr>
+            <a:r>
+              <a:rPr lang="en-US" sz="1300" dirty="0">
                 <a:solidFill>
                   <a:srgbClr val="1B2430"/>
                 </a:solidFill>
-                <a:latin typeface="Cambria" pitchFamily="34" charset="0"/>
-                <a:ea typeface="Cambria" pitchFamily="34" charset="-122"/>
-                <a:cs typeface="Cambria" pitchFamily="34" charset="-120"/>
-              </a:rPr>
-              <a:t>24 / 24</a:t>
-            </a:r>
-            <a:endParaRPr lang="en-US" sz="4000" dirty="0"/>
-          </a:p>
-        </p:txBody>
-      </p:sp>
-      <p:sp>
-        <p:nvSpPr>
-          <p:cNvPr id="12" name="Text 10"/>
-          <p:cNvSpPr txBox="1"/>
-          <p:nvPr/>
-        </p:nvSpPr>
-        <p:spPr>
-          <a:xfrm>
-            <a:off x="685800" y="3566160"/>
-            <a:ext cx="3566160" cy="502920"/>
-          </a:xfrm>
-          <a:prstGeom prst="rect">
-            <a:avLst/>
-          </a:prstGeom>
-          <a:noFill/>
-          <a:ln/>
-        </p:spPr>
-        <p:txBody>
-          <a:bodyPr wrap="square" lIns="0" tIns="0" rIns="0" bIns="0" rtlCol="0" anchor="ctr"/>
-          <a:lstStyle/>
-          <a:p>
-            <a:pPr indent="0" marL="0">
-              <a:buNone/>
+                <a:latin typeface="Calibri" pitchFamily="34" charset="0"/>
+                <a:ea typeface="Calibri" pitchFamily="34" charset="-122"/>
+                <a:cs typeface="Calibri" pitchFamily="34" charset="-120"/>
+              </a:rPr>
+              <a:t>Numbers parsed exactly in one pass (Clinger's fast path)</a:t>
+            </a:r>
+            <a:endParaRPr lang="en-US" sz="1300" dirty="0"/>
+          </a:p>
+          <a:p>
+            <a:pPr marL="342900" indent="-342900">
+              <a:spcAft>
+                <a:spcPts val="600"/>
+              </a:spcAft>
+              <a:buSzPct val="100000"/>
+              <a:buChar char="•"/>
             </a:pPr>
             <a:r>
               <a:rPr lang="en-US" sz="1300" dirty="0">
                 <a:solidFill>
-                  <a:srgbClr val="5B6573"/>
-                </a:solidFill>
-                <a:latin typeface="Calibri" pitchFamily="34" charset="0"/>
-                <a:ea typeface="Calibri" pitchFamily="34" charset="-122"/>
-                <a:cs typeface="Calibri" pitchFamily="34" charset="-120"/>
-              </a:rPr>
-              <a:t>injected mistakes reported before processing</a:t>
-            </a:r>
-            <a:endParaRPr lang="en-US" sz="1300" dirty="0"/>
-          </a:p>
-        </p:txBody>
-      </p:sp>
-      <p:sp>
-        <p:nvSpPr>
-          <p:cNvPr id="13" name="Shape 11"/>
-          <p:cNvSpPr/>
-          <p:nvPr/>
-        </p:nvSpPr>
-        <p:spPr>
-          <a:xfrm>
-            <a:off x="4663440" y="2788920"/>
-            <a:ext cx="4023360" cy="1463040"/>
-          </a:xfrm>
-          <a:prstGeom prst="roundRect">
-            <a:avLst>
-              <a:gd name="adj" fmla="val 5000"/>
-            </a:avLst>
-          </a:prstGeom>
-          <a:solidFill>
-            <a:srgbClr val="EEF1F4"/>
-          </a:solidFill>
-          <a:ln w="12700">
-            <a:solidFill>
-              <a:srgbClr val="EEF1F4"/>
-            </a:solidFill>
-            <a:prstDash val="solid"/>
-          </a:ln>
-        </p:spPr>
-      </p:sp>
-      <p:sp>
-        <p:nvSpPr>
-          <p:cNvPr id="14" name="Text 12"/>
-          <p:cNvSpPr txBox="1"/>
-          <p:nvPr/>
-        </p:nvSpPr>
-        <p:spPr>
-          <a:xfrm>
-            <a:off x="4892040" y="2880360"/>
-            <a:ext cx="3566160" cy="685800"/>
-          </a:xfrm>
-          <a:prstGeom prst="rect">
-            <a:avLst/>
-          </a:prstGeom>
-          <a:noFill/>
-          <a:ln/>
-        </p:spPr>
-        <p:txBody>
-          <a:bodyPr wrap="square" lIns="0" tIns="0" rIns="0" bIns="0" rtlCol="0" anchor="ctr"/>
-          <a:lstStyle/>
-          <a:p>
-            <a:pPr indent="0" marL="0">
-              <a:buNone/>
-            </a:pPr>
-            <a:r>
-              <a:rPr lang="en-US" sz="4000" b="1" dirty="0">
-                <a:solidFill>
-                  <a:srgbClr val="23867A"/>
-                </a:solidFill>
-                <a:latin typeface="Cambria" pitchFamily="34" charset="0"/>
-                <a:ea typeface="Cambria" pitchFamily="34" charset="-122"/>
-                <a:cs typeface="Cambria" pitchFamily="34" charset="-120"/>
-              </a:rPr>
-              <a:t>18 / 44</a:t>
-            </a:r>
-            <a:endParaRPr lang="en-US" sz="4000" dirty="0"/>
-          </a:p>
-        </p:txBody>
-      </p:sp>
-      <p:sp>
-        <p:nvSpPr>
-          <p:cNvPr id="15" name="Text 13"/>
-          <p:cNvSpPr txBox="1"/>
-          <p:nvPr/>
-        </p:nvSpPr>
-        <p:spPr>
-          <a:xfrm>
-            <a:off x="4892040" y="3566160"/>
-            <a:ext cx="3566160" cy="502920"/>
-          </a:xfrm>
-          <a:prstGeom prst="rect">
-            <a:avLst/>
-          </a:prstGeom>
-          <a:noFill/>
-          <a:ln/>
-        </p:spPr>
-        <p:txBody>
-          <a:bodyPr wrap="square" lIns="0" tIns="0" rIns="0" bIns="0" rtlCol="0" anchor="ctr"/>
-          <a:lstStyle/>
-          <a:p>
-            <a:pPr indent="0" marL="0">
-              <a:buNone/>
-            </a:pPr>
-            <a:r>
-              <a:rPr lang="en-US" sz="1300" dirty="0">
-                <a:solidFill>
-                  <a:srgbClr val="5B6573"/>
-                </a:solidFill>
-                <a:latin typeface="Calibri" pitchFamily="34" charset="0"/>
-                <a:ea typeface="Calibri" pitchFamily="34" charset="-122"/>
-                <a:cs typeface="Calibri" pitchFamily="34" charset="-120"/>
-              </a:rPr>
-              <a:t>real GitHub failures reported before processing</a:t>
+                  <a:srgbClr val="1B2430"/>
+                </a:solidFill>
+                <a:latin typeface="Calibri" pitchFamily="34" charset="0"/>
+                <a:ea typeface="Calibri" pitchFamily="34" charset="-122"/>
+                <a:cs typeface="Calibri" pitchFamily="34" charset="-120"/>
+              </a:rPr>
+              <a:t>CRC-32 on its own thread; merge in file order gives the same facts and line numbers</a:t>
             </a:r>
             <a:endParaRPr lang="en-US" sz="1300" dirty="0"/>
           </a:p>
@@ -3507,7 +3621,7 @@
                 <a:ea typeface="Cambria" pitchFamily="34" charset="-122"/>
                 <a:cs typeface="Cambria" pitchFamily="34" charset="-120"/>
               </a:rPr>
-              <a:t>Demonstration</a:t>
+              <a:t>Testing and evaluation</a:t>
             </a:r>
             <a:endParaRPr lang="en-US" sz="2800" dirty="0"/>
           </a:p>
@@ -3522,17 +3636,19 @@
         <p:spPr>
           <a:xfrm>
             <a:off x="457200" y="1097280"/>
-            <a:ext cx="384048" cy="384048"/>
-          </a:xfrm>
-          <a:prstGeom prst="ellipse">
-            <a:avLst/>
+            <a:ext cx="4023360" cy="1463040"/>
+          </a:xfrm>
+          <a:prstGeom prst="roundRect">
+            <a:avLst>
+              <a:gd name="adj" fmla="val 5000"/>
+            </a:avLst>
           </a:prstGeom>
           <a:solidFill>
-            <a:srgbClr val="E8A33D"/>
+            <a:srgbClr val="EEF1F4"/>
           </a:solidFill>
           <a:ln w="12700">
             <a:solidFill>
-              <a:srgbClr val="E8A33D"/>
+              <a:srgbClr val="EEF1F4"/>
             </a:solidFill>
             <a:prstDash val="solid"/>
           </a:ln>
@@ -3546,34 +3662,34 @@
         </p:nvSpPr>
         <p:spPr>
           <a:xfrm>
-            <a:off x="457200" y="1097280"/>
-            <a:ext cx="384048" cy="384048"/>
-          </a:xfrm>
-          <a:prstGeom prst="rect">
-            <a:avLst/>
-          </a:prstGeom>
-          <a:noFill/>
-          <a:ln/>
-        </p:spPr>
-        <p:txBody>
-          <a:bodyPr wrap="square" lIns="0" tIns="0" rIns="0" bIns="0" rtlCol="0" anchor="ctr"/>
-          <a:lstStyle/>
-          <a:p>
-            <a:pPr algn="ctr" indent="0" marL="0">
-              <a:buNone/>
-            </a:pPr>
-            <a:r>
-              <a:rPr lang="en-US" sz="1400" b="1" dirty="0">
+            <a:off x="685800" y="1188720"/>
+            <a:ext cx="3566160" cy="685800"/>
+          </a:xfrm>
+          <a:prstGeom prst="rect">
+            <a:avLst/>
+          </a:prstGeom>
+          <a:noFill/>
+          <a:ln/>
+        </p:spPr>
+        <p:txBody>
+          <a:bodyPr wrap="square" lIns="0" tIns="0" rIns="0" bIns="0" rtlCol="0" anchor="ctr"/>
+          <a:lstStyle/>
+          <a:p>
+            <a:pPr indent="0" marL="0">
+              <a:buNone/>
+            </a:pPr>
+            <a:r>
+              <a:rPr lang="en-US" sz="4000" b="1" dirty="0">
                 <a:solidFill>
                   <a:srgbClr val="1B2430"/>
                 </a:solidFill>
-                <a:latin typeface="Calibri" pitchFamily="34" charset="0"/>
-                <a:ea typeface="Calibri" pitchFamily="34" charset="-122"/>
-                <a:cs typeface="Calibri" pitchFamily="34" charset="-120"/>
-              </a:rPr>
-              <a:t>1</a:t>
-            </a:r>
-            <a:endParaRPr lang="en-US" sz="1400" dirty="0"/>
+                <a:latin typeface="Cambria" pitchFamily="34" charset="0"/>
+                <a:ea typeface="Cambria" pitchFamily="34" charset="-122"/>
+                <a:cs typeface="Cambria" pitchFamily="34" charset="-120"/>
+              </a:rPr>
+              <a:t>207</a:t>
+            </a:r>
+            <a:endParaRPr lang="en-US" sz="4000" dirty="0"/>
           </a:p>
         </p:txBody>
       </p:sp>
@@ -3585,63 +3701,24 @@
         </p:nvSpPr>
         <p:spPr>
           <a:xfrm>
-            <a:off x="1005840" y="1133856"/>
-            <a:ext cx="2194560" cy="320040"/>
-          </a:xfrm>
-          <a:prstGeom prst="rect">
-            <a:avLst/>
-          </a:prstGeom>
-          <a:noFill/>
-          <a:ln/>
-        </p:spPr>
-        <p:txBody>
-          <a:bodyPr wrap="square" lIns="0" tIns="0" rIns="0" bIns="0" rtlCol="0" anchor="ctr"/>
-          <a:lstStyle/>
-          <a:p>
-            <a:pPr indent="0" marL="0">
-              <a:buNone/>
-            </a:pPr>
-            <a:r>
-              <a:rPr lang="en-US" sz="1600" b="1" dirty="0">
-                <a:solidFill>
-                  <a:srgbClr val="1B2430"/>
-                </a:solidFill>
-                <a:latin typeface="Calibri" pitchFamily="34" charset="0"/>
-                <a:ea typeface="Calibri" pitchFamily="34" charset="-122"/>
-                <a:cs typeface="Calibri" pitchFamily="34" charset="-120"/>
-              </a:rPr>
-              <a:t>Build</a:t>
-            </a:r>
-            <a:endParaRPr lang="en-US" sz="1600" dirty="0"/>
-          </a:p>
-        </p:txBody>
-      </p:sp>
-      <p:sp>
-        <p:nvSpPr>
-          <p:cNvPr id="7" name="Text 5"/>
-          <p:cNvSpPr txBox="1"/>
-          <p:nvPr/>
-        </p:nvSpPr>
-        <p:spPr>
-          <a:xfrm>
-            <a:off x="3200400" y="1133856"/>
-            <a:ext cx="5486400" cy="320040"/>
-          </a:xfrm>
-          <a:prstGeom prst="rect">
-            <a:avLst/>
-          </a:prstGeom>
-          <a:noFill/>
-          <a:ln/>
-        </p:spPr>
-        <p:txBody>
-          <a:bodyPr wrap="square" lIns="0" tIns="0" rIns="0" bIns="0" rtlCol="0" anchor="ctr"/>
-          <a:lstStyle/>
-          <a:p>
-            <a:pPr indent="0" marL="0">
-              <a:buNone/>
-            </a:pPr>
-            <a:r>
-              <a:rPr lang="en-US" sz="1500" dirty="0">
+            <a:off x="685800" y="1874520"/>
+            <a:ext cx="3566160" cy="502920"/>
+          </a:xfrm>
+          <a:prstGeom prst="rect">
+            <a:avLst/>
+          </a:prstGeom>
+          <a:noFill/>
+          <a:ln/>
+        </p:spPr>
+        <p:txBody>
+          <a:bodyPr wrap="square" lIns="0" tIns="0" rIns="0" bIns="0" rtlCol="0" anchor="ctr"/>
+          <a:lstStyle/>
+          <a:p>
+            <a:pPr indent="0" marL="0">
+              <a:buNone/>
+            </a:pPr>
+            <a:r>
+              <a:rPr lang="en-US" sz="1300" dirty="0">
                 <a:solidFill>
                   <a:srgbClr val="5B6573"/>
                 </a:solidFill>
@@ -3649,32 +3726,34 @@
                 <a:ea typeface="Calibri" pitchFamily="34" charset="-122"/>
                 <a:cs typeface="Calibri" pitchFamily="34" charset="-120"/>
               </a:rPr>
-              <a:t>Ctrl + Shift + B in VS Code</a:t>
-            </a:r>
-            <a:endParaRPr lang="en-US" sz="1500" dirty="0"/>
-          </a:p>
-        </p:txBody>
-      </p:sp>
-      <p:sp>
-        <p:nvSpPr>
-          <p:cNvPr id="8" name="Shape 6"/>
+              <a:t>unit tests in 9 programs, all passing</a:t>
+            </a:r>
+            <a:endParaRPr lang="en-US" sz="1300" dirty="0"/>
+          </a:p>
+        </p:txBody>
+      </p:sp>
+      <p:sp>
+        <p:nvSpPr>
+          <p:cNvPr id="7" name="Shape 5"/>
           <p:cNvSpPr/>
           <p:nvPr/>
         </p:nvSpPr>
         <p:spPr>
           <a:xfrm>
-            <a:off x="457200" y="1810512"/>
-            <a:ext cx="384048" cy="384048"/>
-          </a:xfrm>
-          <a:prstGeom prst="ellipse">
-            <a:avLst/>
+            <a:off x="4663440" y="1097280"/>
+            <a:ext cx="4023360" cy="1463040"/>
+          </a:xfrm>
+          <a:prstGeom prst="roundRect">
+            <a:avLst>
+              <a:gd name="adj" fmla="val 5000"/>
+            </a:avLst>
           </a:prstGeom>
           <a:solidFill>
-            <a:srgbClr val="E8A33D"/>
+            <a:srgbClr val="EEF1F4"/>
           </a:solidFill>
           <a:ln w="12700">
             <a:solidFill>
-              <a:srgbClr val="E8A33D"/>
+              <a:srgbClr val="EEF1F4"/>
             </a:solidFill>
             <a:prstDash val="solid"/>
           </a:ln>
@@ -3682,108 +3761,69 @@
       </p:sp>
       <p:sp>
         <p:nvSpPr>
+          <p:cNvPr id="8" name="Text 6"/>
+          <p:cNvSpPr txBox="1"/>
+          <p:nvPr/>
+        </p:nvSpPr>
+        <p:spPr>
+          <a:xfrm>
+            <a:off x="4892040" y="1188720"/>
+            <a:ext cx="3566160" cy="685800"/>
+          </a:xfrm>
+          <a:prstGeom prst="rect">
+            <a:avLst/>
+          </a:prstGeom>
+          <a:noFill/>
+          <a:ln/>
+        </p:spPr>
+        <p:txBody>
+          <a:bodyPr wrap="square" lIns="0" tIns="0" rIns="0" bIns="0" rtlCol="0" anchor="ctr"/>
+          <a:lstStyle/>
+          <a:p>
+            <a:pPr indent="0" marL="0">
+              <a:buNone/>
+            </a:pPr>
+            <a:r>
+              <a:rPr lang="en-US" sz="4000" b="1" dirty="0">
+                <a:solidFill>
+                  <a:srgbClr val="23867A"/>
+                </a:solidFill>
+                <a:latin typeface="Cambria" pitchFamily="34" charset="0"/>
+                <a:ea typeface="Cambria" pitchFamily="34" charset="-122"/>
+                <a:cs typeface="Cambria" pitchFamily="34" charset="-120"/>
+              </a:rPr>
+              <a:t>17</a:t>
+            </a:r>
+            <a:endParaRPr lang="en-US" sz="4000" dirty="0"/>
+          </a:p>
+        </p:txBody>
+      </p:sp>
+      <p:sp>
+        <p:nvSpPr>
           <p:cNvPr id="9" name="Text 7"/>
           <p:cNvSpPr txBox="1"/>
           <p:nvPr/>
         </p:nvSpPr>
         <p:spPr>
           <a:xfrm>
-            <a:off x="457200" y="1810512"/>
-            <a:ext cx="384048" cy="384048"/>
-          </a:xfrm>
-          <a:prstGeom prst="rect">
-            <a:avLst/>
-          </a:prstGeom>
-          <a:noFill/>
-          <a:ln/>
-        </p:spPr>
-        <p:txBody>
-          <a:bodyPr wrap="square" lIns="0" tIns="0" rIns="0" bIns="0" rtlCol="0" anchor="ctr"/>
-          <a:lstStyle/>
-          <a:p>
-            <a:pPr algn="ctr" indent="0" marL="0">
-              <a:buNone/>
-            </a:pPr>
-            <a:r>
-              <a:rPr lang="en-US" sz="1400" b="1" dirty="0">
-                <a:solidFill>
-                  <a:srgbClr val="1B2430"/>
-                </a:solidFill>
-                <a:latin typeface="Calibri" pitchFamily="34" charset="0"/>
-                <a:ea typeface="Calibri" pitchFamily="34" charset="-122"/>
-                <a:cs typeface="Calibri" pitchFamily="34" charset="-120"/>
-              </a:rPr>
-              <a:t>2</a:t>
-            </a:r>
-            <a:endParaRPr lang="en-US" sz="1400" dirty="0"/>
-          </a:p>
-        </p:txBody>
-      </p:sp>
-      <p:sp>
-        <p:nvSpPr>
-          <p:cNvPr id="10" name="Text 8"/>
-          <p:cNvSpPr txBox="1"/>
-          <p:nvPr/>
-        </p:nvSpPr>
-        <p:spPr>
-          <a:xfrm>
-            <a:off x="1005840" y="1847088"/>
-            <a:ext cx="2194560" cy="320040"/>
-          </a:xfrm>
-          <a:prstGeom prst="rect">
-            <a:avLst/>
-          </a:prstGeom>
-          <a:noFill/>
-          <a:ln/>
-        </p:spPr>
-        <p:txBody>
-          <a:bodyPr wrap="square" lIns="0" tIns="0" rIns="0" bIns="0" rtlCol="0" anchor="ctr"/>
-          <a:lstStyle/>
-          <a:p>
-            <a:pPr indent="0" marL="0">
-              <a:buNone/>
-            </a:pPr>
-            <a:r>
-              <a:rPr lang="en-US" sz="1600" b="1" dirty="0">
-                <a:solidFill>
-                  <a:srgbClr val="1B2430"/>
-                </a:solidFill>
-                <a:latin typeface="Calibri" pitchFamily="34" charset="0"/>
-                <a:ea typeface="Calibri" pitchFamily="34" charset="-122"/>
-                <a:cs typeface="Calibri" pitchFamily="34" charset="-120"/>
-              </a:rPr>
-              <a:t>Compile and run</a:t>
-            </a:r>
-            <a:endParaRPr lang="en-US" sz="1600" dirty="0"/>
-          </a:p>
-        </p:txBody>
-      </p:sp>
-      <p:sp>
-        <p:nvSpPr>
-          <p:cNvPr id="11" name="Text 9"/>
-          <p:cNvSpPr txBox="1"/>
-          <p:nvPr/>
-        </p:nvSpPr>
-        <p:spPr>
-          <a:xfrm>
-            <a:off x="3200400" y="1847088"/>
-            <a:ext cx="5486400" cy="320040"/>
-          </a:xfrm>
-          <a:prstGeom prst="rect">
-            <a:avLst/>
-          </a:prstGeom>
-          <a:noFill/>
-          <a:ln/>
-        </p:spPr>
-        <p:txBody>
-          <a:bodyPr wrap="square" lIns="0" tIns="0" rIns="0" bIns="0" rtlCol="0" anchor="ctr"/>
-          <a:lstStyle/>
-          <a:p>
-            <a:pPr indent="0" marL="0">
-              <a:buNone/>
-            </a:pPr>
-            <a:r>
-              <a:rPr lang="en-US" sz="1500" dirty="0">
+            <a:off x="4892040" y="1874520"/>
+            <a:ext cx="3566160" cy="502920"/>
+          </a:xfrm>
+          <a:prstGeom prst="rect">
+            <a:avLst/>
+          </a:prstGeom>
+          <a:noFill/>
+          <a:ln/>
+        </p:spPr>
+        <p:txBody>
+          <a:bodyPr wrap="square" lIns="0" tIns="0" rIns="0" bIns="0" rtlCol="0" anchor="ctr"/>
+          <a:lstStyle/>
+          <a:p>
+            <a:pPr indent="0" marL="0">
+              <a:buNone/>
+            </a:pPr>
+            <a:r>
+              <a:rPr lang="en-US" sz="1300" dirty="0">
                 <a:solidFill>
                   <a:srgbClr val="5B6573"/>
                 </a:solidFill>
@@ -3791,32 +3831,34 @@
                 <a:ea typeface="Calibri" pitchFamily="34" charset="-122"/>
                 <a:cs typeface="Calibri" pitchFamily="34" charset="-120"/>
               </a:rPr>
-              <a:t>students.prep: every phase, then the cleaned file</a:t>
-            </a:r>
-            <a:endParaRPr lang="en-US" sz="1500" dirty="0"/>
-          </a:p>
-        </p:txBody>
-      </p:sp>
-      <p:sp>
-        <p:nvSpPr>
-          <p:cNvPr id="12" name="Shape 10"/>
+              <a:t>recorded test cases: valid, invalid, boundary, run time</a:t>
+            </a:r>
+            <a:endParaRPr lang="en-US" sz="1300" dirty="0"/>
+          </a:p>
+        </p:txBody>
+      </p:sp>
+      <p:sp>
+        <p:nvSpPr>
+          <p:cNvPr id="10" name="Shape 8"/>
           <p:cNvSpPr/>
           <p:nvPr/>
         </p:nvSpPr>
         <p:spPr>
           <a:xfrm>
-            <a:off x="457200" y="2523744"/>
-            <a:ext cx="384048" cy="384048"/>
-          </a:xfrm>
-          <a:prstGeom prst="ellipse">
-            <a:avLst/>
+            <a:off x="457200" y="2788920"/>
+            <a:ext cx="4023360" cy="1463040"/>
+          </a:xfrm>
+          <a:prstGeom prst="roundRect">
+            <a:avLst>
+              <a:gd name="adj" fmla="val 5000"/>
+            </a:avLst>
           </a:prstGeom>
           <a:solidFill>
-            <a:srgbClr val="E8A33D"/>
+            <a:srgbClr val="EEF1F4"/>
           </a:solidFill>
           <a:ln w="12700">
             <a:solidFill>
-              <a:srgbClr val="E8A33D"/>
+              <a:srgbClr val="EEF1F4"/>
             </a:solidFill>
             <a:prstDash val="solid"/>
           </a:ln>
@@ -3824,108 +3866,69 @@
       </p:sp>
       <p:sp>
         <p:nvSpPr>
-          <p:cNvPr id="13" name="Text 11"/>
-          <p:cNvSpPr txBox="1"/>
-          <p:nvPr/>
-        </p:nvSpPr>
-        <p:spPr>
-          <a:xfrm>
-            <a:off x="457200" y="2523744"/>
-            <a:ext cx="384048" cy="384048"/>
-          </a:xfrm>
-          <a:prstGeom prst="rect">
-            <a:avLst/>
-          </a:prstGeom>
-          <a:noFill/>
-          <a:ln/>
-        </p:spPr>
-        <p:txBody>
-          <a:bodyPr wrap="square" lIns="0" tIns="0" rIns="0" bIns="0" rtlCol="0" anchor="ctr"/>
-          <a:lstStyle/>
-          <a:p>
-            <a:pPr algn="ctr" indent="0" marL="0">
-              <a:buNone/>
-            </a:pPr>
-            <a:r>
-              <a:rPr lang="en-US" sz="1400" b="1" dirty="0">
+          <p:cNvPr id="11" name="Text 9"/>
+          <p:cNvSpPr txBox="1"/>
+          <p:nvPr/>
+        </p:nvSpPr>
+        <p:spPr>
+          <a:xfrm>
+            <a:off x="685800" y="2880360"/>
+            <a:ext cx="3566160" cy="685800"/>
+          </a:xfrm>
+          <a:prstGeom prst="rect">
+            <a:avLst/>
+          </a:prstGeom>
+          <a:noFill/>
+          <a:ln/>
+        </p:spPr>
+        <p:txBody>
+          <a:bodyPr wrap="square" lIns="0" tIns="0" rIns="0" bIns="0" rtlCol="0" anchor="ctr"/>
+          <a:lstStyle/>
+          <a:p>
+            <a:pPr indent="0" marL="0">
+              <a:buNone/>
+            </a:pPr>
+            <a:r>
+              <a:rPr lang="en-US" sz="4000" b="1" dirty="0">
                 <a:solidFill>
                   <a:srgbClr val="1B2430"/>
                 </a:solidFill>
-                <a:latin typeface="Calibri" pitchFamily="34" charset="0"/>
-                <a:ea typeface="Calibri" pitchFamily="34" charset="-122"/>
-                <a:cs typeface="Calibri" pitchFamily="34" charset="-120"/>
-              </a:rPr>
-              <a:t>3</a:t>
-            </a:r>
-            <a:endParaRPr lang="en-US" sz="1400" dirty="0"/>
-          </a:p>
-        </p:txBody>
-      </p:sp>
-      <p:sp>
-        <p:nvSpPr>
-          <p:cNvPr id="14" name="Text 12"/>
-          <p:cNvSpPr txBox="1"/>
-          <p:nvPr/>
-        </p:nvSpPr>
-        <p:spPr>
-          <a:xfrm>
-            <a:off x="1005840" y="2560320"/>
-            <a:ext cx="2194560" cy="320040"/>
-          </a:xfrm>
-          <a:prstGeom prst="rect">
-            <a:avLst/>
-          </a:prstGeom>
-          <a:noFill/>
-          <a:ln/>
-        </p:spPr>
-        <p:txBody>
-          <a:bodyPr wrap="square" lIns="0" tIns="0" rIns="0" bIns="0" rtlCol="0" anchor="ctr"/>
-          <a:lstStyle/>
-          <a:p>
-            <a:pPr indent="0" marL="0">
-              <a:buNone/>
-            </a:pPr>
-            <a:r>
-              <a:rPr lang="en-US" sz="1600" b="1" dirty="0">
-                <a:solidFill>
-                  <a:srgbClr val="1B2430"/>
-                </a:solidFill>
-                <a:latin typeface="Calibri" pitchFamily="34" charset="0"/>
-                <a:ea typeface="Calibri" pitchFamily="34" charset="-122"/>
-                <a:cs typeface="Calibri" pitchFamily="34" charset="-120"/>
-              </a:rPr>
-              <a:t>See the errors</a:t>
-            </a:r>
-            <a:endParaRPr lang="en-US" sz="1600" dirty="0"/>
-          </a:p>
-        </p:txBody>
-      </p:sp>
-      <p:sp>
-        <p:nvSpPr>
-          <p:cNvPr id="15" name="Text 13"/>
-          <p:cNvSpPr txBox="1"/>
-          <p:nvPr/>
-        </p:nvSpPr>
-        <p:spPr>
-          <a:xfrm>
-            <a:off x="3200400" y="2560320"/>
-            <a:ext cx="5486400" cy="320040"/>
-          </a:xfrm>
-          <a:prstGeom prst="rect">
-            <a:avLst/>
-          </a:prstGeom>
-          <a:noFill/>
-          <a:ln/>
-        </p:spPr>
-        <p:txBody>
-          <a:bodyPr wrap="square" lIns="0" tIns="0" rIns="0" bIns="0" rtlCol="0" anchor="ctr"/>
-          <a:lstStyle/>
-          <a:p>
-            <a:pPr indent="0" marL="0">
-              <a:buNone/>
-            </a:pPr>
-            <a:r>
-              <a:rPr lang="en-US" sz="1500" dirty="0">
+                <a:latin typeface="Cambria" pitchFamily="34" charset="0"/>
+                <a:ea typeface="Cambria" pitchFamily="34" charset="-122"/>
+                <a:cs typeface="Cambria" pitchFamily="34" charset="-120"/>
+              </a:rPr>
+              <a:t>24 / 24</a:t>
+            </a:r>
+            <a:endParaRPr lang="en-US" sz="4000" dirty="0"/>
+          </a:p>
+        </p:txBody>
+      </p:sp>
+      <p:sp>
+        <p:nvSpPr>
+          <p:cNvPr id="12" name="Text 10"/>
+          <p:cNvSpPr txBox="1"/>
+          <p:nvPr/>
+        </p:nvSpPr>
+        <p:spPr>
+          <a:xfrm>
+            <a:off x="685800" y="3566160"/>
+            <a:ext cx="3566160" cy="502920"/>
+          </a:xfrm>
+          <a:prstGeom prst="rect">
+            <a:avLst/>
+          </a:prstGeom>
+          <a:noFill/>
+          <a:ln/>
+        </p:spPr>
+        <p:txBody>
+          <a:bodyPr wrap="square" lIns="0" tIns="0" rIns="0" bIns="0" rtlCol="0" anchor="ctr"/>
+          <a:lstStyle/>
+          <a:p>
+            <a:pPr indent="0" marL="0">
+              <a:buNone/>
+            </a:pPr>
+            <a:r>
+              <a:rPr lang="en-US" sz="1300" dirty="0">
                 <a:solidFill>
                   <a:srgbClr val="5B6573"/>
                 </a:solidFill>
@@ -3933,32 +3936,34 @@
                 <a:ea typeface="Calibri" pitchFamily="34" charset="-122"/>
                 <a:cs typeface="Calibri" pitchFamily="34" charset="-120"/>
               </a:rPr>
-              <a:t>examples/errors: line, caret and hint</a:t>
-            </a:r>
-            <a:endParaRPr lang="en-US" sz="1500" dirty="0"/>
-          </a:p>
-        </p:txBody>
-      </p:sp>
-      <p:sp>
-        <p:nvSpPr>
-          <p:cNvPr id="16" name="Shape 14"/>
+              <a:t>injected mistakes reported before processing</a:t>
+            </a:r>
+            <a:endParaRPr lang="en-US" sz="1300" dirty="0"/>
+          </a:p>
+        </p:txBody>
+      </p:sp>
+      <p:sp>
+        <p:nvSpPr>
+          <p:cNvPr id="13" name="Shape 11"/>
           <p:cNvSpPr/>
           <p:nvPr/>
         </p:nvSpPr>
         <p:spPr>
           <a:xfrm>
-            <a:off x="457200" y="3236976"/>
-            <a:ext cx="384048" cy="384048"/>
-          </a:xfrm>
-          <a:prstGeom prst="ellipse">
-            <a:avLst/>
+            <a:off x="4663440" y="2788920"/>
+            <a:ext cx="4023360" cy="1463040"/>
+          </a:xfrm>
+          <a:prstGeom prst="roundRect">
+            <a:avLst>
+              <a:gd name="adj" fmla="val 5000"/>
+            </a:avLst>
           </a:prstGeom>
           <a:solidFill>
-            <a:srgbClr val="E8A33D"/>
+            <a:srgbClr val="EEF1F4"/>
           </a:solidFill>
           <a:ln w="12700">
             <a:solidFill>
-              <a:srgbClr val="E8A33D"/>
+              <a:srgbClr val="EEF1F4"/>
             </a:solidFill>
             <a:prstDash val="solid"/>
           </a:ln>
@@ -3966,108 +3971,69 @@
       </p:sp>
       <p:sp>
         <p:nvSpPr>
-          <p:cNvPr id="17" name="Text 15"/>
-          <p:cNvSpPr txBox="1"/>
-          <p:nvPr/>
-        </p:nvSpPr>
-        <p:spPr>
-          <a:xfrm>
-            <a:off x="457200" y="3236976"/>
-            <a:ext cx="384048" cy="384048"/>
-          </a:xfrm>
-          <a:prstGeom prst="rect">
-            <a:avLst/>
-          </a:prstGeom>
-          <a:noFill/>
-          <a:ln/>
-        </p:spPr>
-        <p:txBody>
-          <a:bodyPr wrap="square" lIns="0" tIns="0" rIns="0" bIns="0" rtlCol="0" anchor="ctr"/>
-          <a:lstStyle/>
-          <a:p>
-            <a:pPr algn="ctr" indent="0" marL="0">
-              <a:buNone/>
-            </a:pPr>
-            <a:r>
-              <a:rPr lang="en-US" sz="1400" b="1" dirty="0">
-                <a:solidFill>
-                  <a:srgbClr val="1B2430"/>
-                </a:solidFill>
-                <a:latin typeface="Calibri" pitchFamily="34" charset="0"/>
-                <a:ea typeface="Calibri" pitchFamily="34" charset="-122"/>
-                <a:cs typeface="Calibri" pitchFamily="34" charset="-120"/>
-              </a:rPr>
-              <a:t>4</a:t>
-            </a:r>
-            <a:endParaRPr lang="en-US" sz="1400" dirty="0"/>
-          </a:p>
-        </p:txBody>
-      </p:sp>
-      <p:sp>
-        <p:nvSpPr>
-          <p:cNvPr id="18" name="Text 16"/>
-          <p:cNvSpPr txBox="1"/>
-          <p:nvPr/>
-        </p:nvSpPr>
-        <p:spPr>
-          <a:xfrm>
-            <a:off x="1005840" y="3273552"/>
-            <a:ext cx="2194560" cy="320040"/>
-          </a:xfrm>
-          <a:prstGeom prst="rect">
-            <a:avLst/>
-          </a:prstGeom>
-          <a:noFill/>
-          <a:ln/>
-        </p:spPr>
-        <p:txBody>
-          <a:bodyPr wrap="square" lIns="0" tIns="0" rIns="0" bIns="0" rtlCol="0" anchor="ctr"/>
-          <a:lstStyle/>
-          <a:p>
-            <a:pPr indent="0" marL="0">
-              <a:buNone/>
-            </a:pPr>
-            <a:r>
-              <a:rPr lang="en-US" sz="1600" b="1" dirty="0">
-                <a:solidFill>
-                  <a:srgbClr val="1B2430"/>
-                </a:solidFill>
-                <a:latin typeface="Calibri" pitchFamily="34" charset="0"/>
-                <a:ea typeface="Calibri" pitchFamily="34" charset="-122"/>
-                <a:cs typeface="Calibri" pitchFamily="34" charset="-120"/>
-              </a:rPr>
-              <a:t>Certificate</a:t>
-            </a:r>
-            <a:endParaRPr lang="en-US" sz="1600" dirty="0"/>
-          </a:p>
-        </p:txBody>
-      </p:sp>
-      <p:sp>
-        <p:nvSpPr>
-          <p:cNvPr id="19" name="Text 17"/>
-          <p:cNvSpPr txBox="1"/>
-          <p:nvPr/>
-        </p:nvSpPr>
-        <p:spPr>
-          <a:xfrm>
-            <a:off x="3200400" y="3273552"/>
-            <a:ext cx="5486400" cy="320040"/>
-          </a:xfrm>
-          <a:prstGeom prst="rect">
-            <a:avLst/>
-          </a:prstGeom>
-          <a:noFill/>
-          <a:ln/>
-        </p:spPr>
-        <p:txBody>
-          <a:bodyPr wrap="square" lIns="0" tIns="0" rIns="0" bIns="0" rtlCol="0" anchor="ctr"/>
-          <a:lstStyle/>
-          <a:p>
-            <a:pPr indent="0" marL="0">
-              <a:buNone/>
-            </a:pPr>
-            <a:r>
-              <a:rPr lang="en-US" sz="1500" dirty="0">
+          <p:cNvPr id="14" name="Text 12"/>
+          <p:cNvSpPr txBox="1"/>
+          <p:nvPr/>
+        </p:nvSpPr>
+        <p:spPr>
+          <a:xfrm>
+            <a:off x="4892040" y="2880360"/>
+            <a:ext cx="3566160" cy="685800"/>
+          </a:xfrm>
+          <a:prstGeom prst="rect">
+            <a:avLst/>
+          </a:prstGeom>
+          <a:noFill/>
+          <a:ln/>
+        </p:spPr>
+        <p:txBody>
+          <a:bodyPr wrap="square" lIns="0" tIns="0" rIns="0" bIns="0" rtlCol="0" anchor="ctr"/>
+          <a:lstStyle/>
+          <a:p>
+            <a:pPr indent="0" marL="0">
+              <a:buNone/>
+            </a:pPr>
+            <a:r>
+              <a:rPr lang="en-US" sz="4000" b="1" dirty="0">
+                <a:solidFill>
+                  <a:srgbClr val="23867A"/>
+                </a:solidFill>
+                <a:latin typeface="Cambria" pitchFamily="34" charset="0"/>
+                <a:ea typeface="Cambria" pitchFamily="34" charset="-122"/>
+                <a:cs typeface="Cambria" pitchFamily="34" charset="-120"/>
+              </a:rPr>
+              <a:t>18 / 44</a:t>
+            </a:r>
+            <a:endParaRPr lang="en-US" sz="4000" dirty="0"/>
+          </a:p>
+        </p:txBody>
+      </p:sp>
+      <p:sp>
+        <p:nvSpPr>
+          <p:cNvPr id="15" name="Text 13"/>
+          <p:cNvSpPr txBox="1"/>
+          <p:nvPr/>
+        </p:nvSpPr>
+        <p:spPr>
+          <a:xfrm>
+            <a:off x="4892040" y="3566160"/>
+            <a:ext cx="3566160" cy="502920"/>
+          </a:xfrm>
+          <a:prstGeom prst="rect">
+            <a:avLst/>
+          </a:prstGeom>
+          <a:noFill/>
+          <a:ln/>
+        </p:spPr>
+        <p:txBody>
+          <a:bodyPr wrap="square" lIns="0" tIns="0" rIns="0" bIns="0" rtlCol="0" anchor="ctr"/>
+          <a:lstStyle/>
+          <a:p>
+            <a:pPr indent="0" marL="0">
+              <a:buNone/>
+            </a:pPr>
+            <a:r>
+              <a:rPr lang="en-US" sz="1300" dirty="0">
                 <a:solidFill>
                   <a:srgbClr val="5B6573"/>
                 </a:solidFill>
@@ -4075,151 +4041,9 @@
                 <a:ea typeface="Calibri" pitchFamily="34" charset="-122"/>
                 <a:cs typeface="Calibri" pitchFamily="34" charset="-120"/>
               </a:rPr>
-              <a:t>--certificate, then run on a new batch and a bad one</a:t>
-            </a:r>
-            <a:endParaRPr lang="en-US" sz="1500" dirty="0"/>
-          </a:p>
-        </p:txBody>
-      </p:sp>
-      <p:sp>
-        <p:nvSpPr>
-          <p:cNvPr id="20" name="Shape 18"/>
-          <p:cNvSpPr/>
-          <p:nvPr/>
-        </p:nvSpPr>
-        <p:spPr>
-          <a:xfrm>
-            <a:off x="457200" y="3950208"/>
-            <a:ext cx="384048" cy="384048"/>
-          </a:xfrm>
-          <a:prstGeom prst="ellipse">
-            <a:avLst/>
-          </a:prstGeom>
-          <a:solidFill>
-            <a:srgbClr val="E8A33D"/>
-          </a:solidFill>
-          <a:ln w="12700">
-            <a:solidFill>
-              <a:srgbClr val="E8A33D"/>
-            </a:solidFill>
-            <a:prstDash val="solid"/>
-          </a:ln>
-        </p:spPr>
-      </p:sp>
-      <p:sp>
-        <p:nvSpPr>
-          <p:cNvPr id="21" name="Text 19"/>
-          <p:cNvSpPr txBox="1"/>
-          <p:nvPr/>
-        </p:nvSpPr>
-        <p:spPr>
-          <a:xfrm>
-            <a:off x="457200" y="3950208"/>
-            <a:ext cx="384048" cy="384048"/>
-          </a:xfrm>
-          <a:prstGeom prst="rect">
-            <a:avLst/>
-          </a:prstGeom>
-          <a:noFill/>
-          <a:ln/>
-        </p:spPr>
-        <p:txBody>
-          <a:bodyPr wrap="square" lIns="0" tIns="0" rIns="0" bIns="0" rtlCol="0" anchor="ctr"/>
-          <a:lstStyle/>
-          <a:p>
-            <a:pPr algn="ctr" indent="0" marL="0">
-              <a:buNone/>
-            </a:pPr>
-            <a:r>
-              <a:rPr lang="en-US" sz="1400" b="1" dirty="0">
-                <a:solidFill>
-                  <a:srgbClr val="1B2430"/>
-                </a:solidFill>
-                <a:latin typeface="Calibri" pitchFamily="34" charset="0"/>
-                <a:ea typeface="Calibri" pitchFamily="34" charset="-122"/>
-                <a:cs typeface="Calibri" pitchFamily="34" charset="-120"/>
-              </a:rPr>
-              <a:t>5</a:t>
-            </a:r>
-            <a:endParaRPr lang="en-US" sz="1400" dirty="0"/>
-          </a:p>
-        </p:txBody>
-      </p:sp>
-      <p:sp>
-        <p:nvSpPr>
-          <p:cNvPr id="22" name="Text 20"/>
-          <p:cNvSpPr txBox="1"/>
-          <p:nvPr/>
-        </p:nvSpPr>
-        <p:spPr>
-          <a:xfrm>
-            <a:off x="1005840" y="3986784"/>
-            <a:ext cx="2194560" cy="320040"/>
-          </a:xfrm>
-          <a:prstGeom prst="rect">
-            <a:avLst/>
-          </a:prstGeom>
-          <a:noFill/>
-          <a:ln/>
-        </p:spPr>
-        <p:txBody>
-          <a:bodyPr wrap="square" lIns="0" tIns="0" rIns="0" bIns="0" rtlCol="0" anchor="ctr"/>
-          <a:lstStyle/>
-          <a:p>
-            <a:pPr indent="0" marL="0">
-              <a:buNone/>
-            </a:pPr>
-            <a:r>
-              <a:rPr lang="en-US" sz="1600" b="1" dirty="0">
-                <a:solidFill>
-                  <a:srgbClr val="1B2430"/>
-                </a:solidFill>
-                <a:latin typeface="Calibri" pitchFamily="34" charset="0"/>
-                <a:ea typeface="Calibri" pitchFamily="34" charset="-122"/>
-                <a:cs typeface="Calibri" pitchFamily="34" charset="-120"/>
-              </a:rPr>
-              <a:t>Tests</a:t>
-            </a:r>
-            <a:endParaRPr lang="en-US" sz="1600" dirty="0"/>
-          </a:p>
-        </p:txBody>
-      </p:sp>
-      <p:sp>
-        <p:nvSpPr>
-          <p:cNvPr id="23" name="Text 21"/>
-          <p:cNvSpPr txBox="1"/>
-          <p:nvPr/>
-        </p:nvSpPr>
-        <p:spPr>
-          <a:xfrm>
-            <a:off x="3200400" y="3986784"/>
-            <a:ext cx="5486400" cy="320040"/>
-          </a:xfrm>
-          <a:prstGeom prst="rect">
-            <a:avLst/>
-          </a:prstGeom>
-          <a:noFill/>
-          <a:ln/>
-        </p:spPr>
-        <p:txBody>
-          <a:bodyPr wrap="square" lIns="0" tIns="0" rIns="0" bIns="0" rtlCol="0" anchor="ctr"/>
-          <a:lstStyle/>
-          <a:p>
-            <a:pPr indent="0" marL="0">
-              <a:buNone/>
-            </a:pPr>
-            <a:r>
-              <a:rPr lang="en-US" sz="1500" dirty="0">
-                <a:solidFill>
-                  <a:srgbClr val="5B6573"/>
-                </a:solidFill>
-                <a:latin typeface="Calibri" pitchFamily="34" charset="0"/>
-                <a:ea typeface="Calibri" pitchFamily="34" charset="-122"/>
-                <a:cs typeface="Calibri" pitchFamily="34" charset="-120"/>
-              </a:rPr>
-              <a:t>run all tests: 9 programs pass</a:t>
-            </a:r>
-            <a:endParaRPr lang="en-US" sz="1500" dirty="0"/>
+              <a:t>real GitHub failures reported before processing</a:t>
+            </a:r>
+            <a:endParaRPr lang="en-US" sz="1300" dirty="0"/>
           </a:p>
         </p:txBody>
       </p:sp>
@@ -4234,6 +4058,826 @@
 <file path=ppt/slides/slide13.xml><?xml version="1.0" encoding="utf-8"?>
 <p:sld xmlns:a="http://schemas.openxmlformats.org/drawingml/2006/main" xmlns:r="http://schemas.openxmlformats.org/officeDocument/2006/relationships" xmlns:p="http://schemas.openxmlformats.org/presentationml/2006/main">
   <p:cSld name="Slide 13">
+    <p:bg>
+      <p:bgPr>
+        <a:solidFill>
+          <a:srgbClr val="FFFFFF"/>
+        </a:solidFill>
+      </p:bgPr>
+    </p:bg>
+    <p:spTree>
+      <p:nvGrpSpPr>
+        <p:cNvPr id="1" name=""/>
+        <p:cNvGrpSpPr/>
+        <p:nvPr/>
+      </p:nvGrpSpPr>
+      <p:grpSpPr>
+        <a:xfrm>
+          <a:off x="0" y="0"/>
+          <a:ext cx="0" cy="0"/>
+          <a:chOff x="0" y="0"/>
+          <a:chExt cx="0" cy="0"/>
+        </a:xfrm>
+      </p:grpSpPr>
+      <p:sp>
+        <p:nvSpPr>
+          <p:cNvPr id="2" name="Text 0"/>
+          <p:cNvSpPr txBox="1"/>
+          <p:nvPr/>
+        </p:nvSpPr>
+        <p:spPr>
+          <a:xfrm>
+            <a:off x="8412480" y="4754880"/>
+            <a:ext cx="365760" cy="228600"/>
+          </a:xfrm>
+          <a:prstGeom prst="rect">
+            <a:avLst/>
+          </a:prstGeom>
+          <a:noFill/>
+          <a:ln/>
+        </p:spPr>
+        <p:txBody>
+          <a:bodyPr wrap="square" lIns="0" tIns="0" rIns="0" bIns="0" rtlCol="0" anchor="ctr"/>
+          <a:lstStyle/>
+          <a:p>
+            <a:pPr algn="r" indent="0" marL="0">
+              <a:buNone/>
+            </a:pPr>
+            <a:r>
+              <a:rPr lang="en-US" sz="1000" dirty="0">
+                <a:solidFill>
+                  <a:srgbClr val="5B6573"/>
+                </a:solidFill>
+                <a:latin typeface="Calibri" pitchFamily="34" charset="0"/>
+                <a:ea typeface="Calibri" pitchFamily="34" charset="-122"/>
+                <a:cs typeface="Calibri" pitchFamily="34" charset="-120"/>
+              </a:rPr>
+              <a:t>13</a:t>
+            </a:r>
+            <a:endParaRPr lang="en-US" sz="1000" dirty="0"/>
+          </a:p>
+        </p:txBody>
+      </p:sp>
+      <p:sp>
+        <p:nvSpPr>
+          <p:cNvPr id="3" name="Text 1"/>
+          <p:cNvSpPr txBox="1"/>
+          <p:nvPr/>
+        </p:nvSpPr>
+        <p:spPr>
+          <a:xfrm>
+            <a:off x="457200" y="320040"/>
+            <a:ext cx="8229600" cy="548640"/>
+          </a:xfrm>
+          <a:prstGeom prst="rect">
+            <a:avLst/>
+          </a:prstGeom>
+          <a:noFill/>
+          <a:ln/>
+        </p:spPr>
+        <p:txBody>
+          <a:bodyPr wrap="square" lIns="0" tIns="0" rIns="0" bIns="0" rtlCol="0" anchor="ctr"/>
+          <a:lstStyle/>
+          <a:p>
+            <a:pPr indent="0" marL="0">
+              <a:buNone/>
+            </a:pPr>
+            <a:r>
+              <a:rPr lang="en-US" sz="2800" b="1" dirty="0">
+                <a:solidFill>
+                  <a:srgbClr val="1B2430"/>
+                </a:solidFill>
+                <a:latin typeface="Cambria" pitchFamily="34" charset="0"/>
+                <a:ea typeface="Cambria" pitchFamily="34" charset="-122"/>
+                <a:cs typeface="Cambria" pitchFamily="34" charset="-120"/>
+              </a:rPr>
+              <a:t>Demonstration</a:t>
+            </a:r>
+            <a:endParaRPr lang="en-US" sz="2800" dirty="0"/>
+          </a:p>
+        </p:txBody>
+      </p:sp>
+      <p:sp>
+        <p:nvSpPr>
+          <p:cNvPr id="4" name="Shape 2"/>
+          <p:cNvSpPr/>
+          <p:nvPr/>
+        </p:nvSpPr>
+        <p:spPr>
+          <a:xfrm>
+            <a:off x="457200" y="1097280"/>
+            <a:ext cx="384048" cy="384048"/>
+          </a:xfrm>
+          <a:prstGeom prst="ellipse">
+            <a:avLst/>
+          </a:prstGeom>
+          <a:solidFill>
+            <a:srgbClr val="E8A33D"/>
+          </a:solidFill>
+          <a:ln w="12700">
+            <a:solidFill>
+              <a:srgbClr val="E8A33D"/>
+            </a:solidFill>
+            <a:prstDash val="solid"/>
+          </a:ln>
+        </p:spPr>
+      </p:sp>
+      <p:sp>
+        <p:nvSpPr>
+          <p:cNvPr id="5" name="Text 3"/>
+          <p:cNvSpPr txBox="1"/>
+          <p:nvPr/>
+        </p:nvSpPr>
+        <p:spPr>
+          <a:xfrm>
+            <a:off x="457200" y="1097280"/>
+            <a:ext cx="384048" cy="384048"/>
+          </a:xfrm>
+          <a:prstGeom prst="rect">
+            <a:avLst/>
+          </a:prstGeom>
+          <a:noFill/>
+          <a:ln/>
+        </p:spPr>
+        <p:txBody>
+          <a:bodyPr wrap="square" lIns="0" tIns="0" rIns="0" bIns="0" rtlCol="0" anchor="ctr"/>
+          <a:lstStyle/>
+          <a:p>
+            <a:pPr algn="ctr" indent="0" marL="0">
+              <a:buNone/>
+            </a:pPr>
+            <a:r>
+              <a:rPr lang="en-US" sz="1400" b="1" dirty="0">
+                <a:solidFill>
+                  <a:srgbClr val="1B2430"/>
+                </a:solidFill>
+                <a:latin typeface="Calibri" pitchFamily="34" charset="0"/>
+                <a:ea typeface="Calibri" pitchFamily="34" charset="-122"/>
+                <a:cs typeface="Calibri" pitchFamily="34" charset="-120"/>
+              </a:rPr>
+              <a:t>1</a:t>
+            </a:r>
+            <a:endParaRPr lang="en-US" sz="1400" dirty="0"/>
+          </a:p>
+        </p:txBody>
+      </p:sp>
+      <p:sp>
+        <p:nvSpPr>
+          <p:cNvPr id="6" name="Text 4"/>
+          <p:cNvSpPr txBox="1"/>
+          <p:nvPr/>
+        </p:nvSpPr>
+        <p:spPr>
+          <a:xfrm>
+            <a:off x="1005840" y="1133856"/>
+            <a:ext cx="2194560" cy="320040"/>
+          </a:xfrm>
+          <a:prstGeom prst="rect">
+            <a:avLst/>
+          </a:prstGeom>
+          <a:noFill/>
+          <a:ln/>
+        </p:spPr>
+        <p:txBody>
+          <a:bodyPr wrap="square" lIns="0" tIns="0" rIns="0" bIns="0" rtlCol="0" anchor="ctr"/>
+          <a:lstStyle/>
+          <a:p>
+            <a:pPr indent="0" marL="0">
+              <a:buNone/>
+            </a:pPr>
+            <a:r>
+              <a:rPr lang="en-US" sz="1600" b="1" dirty="0">
+                <a:solidFill>
+                  <a:srgbClr val="1B2430"/>
+                </a:solidFill>
+                <a:latin typeface="Calibri" pitchFamily="34" charset="0"/>
+                <a:ea typeface="Calibri" pitchFamily="34" charset="-122"/>
+                <a:cs typeface="Calibri" pitchFamily="34" charset="-120"/>
+              </a:rPr>
+              <a:t>Build</a:t>
+            </a:r>
+            <a:endParaRPr lang="en-US" sz="1600" dirty="0"/>
+          </a:p>
+        </p:txBody>
+      </p:sp>
+      <p:sp>
+        <p:nvSpPr>
+          <p:cNvPr id="7" name="Text 5"/>
+          <p:cNvSpPr txBox="1"/>
+          <p:nvPr/>
+        </p:nvSpPr>
+        <p:spPr>
+          <a:xfrm>
+            <a:off x="3200400" y="1133856"/>
+            <a:ext cx="5486400" cy="320040"/>
+          </a:xfrm>
+          <a:prstGeom prst="rect">
+            <a:avLst/>
+          </a:prstGeom>
+          <a:noFill/>
+          <a:ln/>
+        </p:spPr>
+        <p:txBody>
+          <a:bodyPr wrap="square" lIns="0" tIns="0" rIns="0" bIns="0" rtlCol="0" anchor="ctr"/>
+          <a:lstStyle/>
+          <a:p>
+            <a:pPr indent="0" marL="0">
+              <a:buNone/>
+            </a:pPr>
+            <a:r>
+              <a:rPr lang="en-US" sz="1500" dirty="0">
+                <a:solidFill>
+                  <a:srgbClr val="5B6573"/>
+                </a:solidFill>
+                <a:latin typeface="Calibri" pitchFamily="34" charset="0"/>
+                <a:ea typeface="Calibri" pitchFamily="34" charset="-122"/>
+                <a:cs typeface="Calibri" pitchFamily="34" charset="-120"/>
+              </a:rPr>
+              <a:t>Ctrl + Shift + B in VS Code</a:t>
+            </a:r>
+            <a:endParaRPr lang="en-US" sz="1500" dirty="0"/>
+          </a:p>
+        </p:txBody>
+      </p:sp>
+      <p:sp>
+        <p:nvSpPr>
+          <p:cNvPr id="8" name="Shape 6"/>
+          <p:cNvSpPr/>
+          <p:nvPr/>
+        </p:nvSpPr>
+        <p:spPr>
+          <a:xfrm>
+            <a:off x="457200" y="1810512"/>
+            <a:ext cx="384048" cy="384048"/>
+          </a:xfrm>
+          <a:prstGeom prst="ellipse">
+            <a:avLst/>
+          </a:prstGeom>
+          <a:solidFill>
+            <a:srgbClr val="E8A33D"/>
+          </a:solidFill>
+          <a:ln w="12700">
+            <a:solidFill>
+              <a:srgbClr val="E8A33D"/>
+            </a:solidFill>
+            <a:prstDash val="solid"/>
+          </a:ln>
+        </p:spPr>
+      </p:sp>
+      <p:sp>
+        <p:nvSpPr>
+          <p:cNvPr id="9" name="Text 7"/>
+          <p:cNvSpPr txBox="1"/>
+          <p:nvPr/>
+        </p:nvSpPr>
+        <p:spPr>
+          <a:xfrm>
+            <a:off x="457200" y="1810512"/>
+            <a:ext cx="384048" cy="384048"/>
+          </a:xfrm>
+          <a:prstGeom prst="rect">
+            <a:avLst/>
+          </a:prstGeom>
+          <a:noFill/>
+          <a:ln/>
+        </p:spPr>
+        <p:txBody>
+          <a:bodyPr wrap="square" lIns="0" tIns="0" rIns="0" bIns="0" rtlCol="0" anchor="ctr"/>
+          <a:lstStyle/>
+          <a:p>
+            <a:pPr algn="ctr" indent="0" marL="0">
+              <a:buNone/>
+            </a:pPr>
+            <a:r>
+              <a:rPr lang="en-US" sz="1400" b="1" dirty="0">
+                <a:solidFill>
+                  <a:srgbClr val="1B2430"/>
+                </a:solidFill>
+                <a:latin typeface="Calibri" pitchFamily="34" charset="0"/>
+                <a:ea typeface="Calibri" pitchFamily="34" charset="-122"/>
+                <a:cs typeface="Calibri" pitchFamily="34" charset="-120"/>
+              </a:rPr>
+              <a:t>2</a:t>
+            </a:r>
+            <a:endParaRPr lang="en-US" sz="1400" dirty="0"/>
+          </a:p>
+        </p:txBody>
+      </p:sp>
+      <p:sp>
+        <p:nvSpPr>
+          <p:cNvPr id="10" name="Text 8"/>
+          <p:cNvSpPr txBox="1"/>
+          <p:nvPr/>
+        </p:nvSpPr>
+        <p:spPr>
+          <a:xfrm>
+            <a:off x="1005840" y="1847088"/>
+            <a:ext cx="2194560" cy="320040"/>
+          </a:xfrm>
+          <a:prstGeom prst="rect">
+            <a:avLst/>
+          </a:prstGeom>
+          <a:noFill/>
+          <a:ln/>
+        </p:spPr>
+        <p:txBody>
+          <a:bodyPr wrap="square" lIns="0" tIns="0" rIns="0" bIns="0" rtlCol="0" anchor="ctr"/>
+          <a:lstStyle/>
+          <a:p>
+            <a:pPr indent="0" marL="0">
+              <a:buNone/>
+            </a:pPr>
+            <a:r>
+              <a:rPr lang="en-US" sz="1600" b="1" dirty="0">
+                <a:solidFill>
+                  <a:srgbClr val="1B2430"/>
+                </a:solidFill>
+                <a:latin typeface="Calibri" pitchFamily="34" charset="0"/>
+                <a:ea typeface="Calibri" pitchFamily="34" charset="-122"/>
+                <a:cs typeface="Calibri" pitchFamily="34" charset="-120"/>
+              </a:rPr>
+              <a:t>Compile and run</a:t>
+            </a:r>
+            <a:endParaRPr lang="en-US" sz="1600" dirty="0"/>
+          </a:p>
+        </p:txBody>
+      </p:sp>
+      <p:sp>
+        <p:nvSpPr>
+          <p:cNvPr id="11" name="Text 9"/>
+          <p:cNvSpPr txBox="1"/>
+          <p:nvPr/>
+        </p:nvSpPr>
+        <p:spPr>
+          <a:xfrm>
+            <a:off x="3200400" y="1847088"/>
+            <a:ext cx="5486400" cy="320040"/>
+          </a:xfrm>
+          <a:prstGeom prst="rect">
+            <a:avLst/>
+          </a:prstGeom>
+          <a:noFill/>
+          <a:ln/>
+        </p:spPr>
+        <p:txBody>
+          <a:bodyPr wrap="square" lIns="0" tIns="0" rIns="0" bIns="0" rtlCol="0" anchor="ctr"/>
+          <a:lstStyle/>
+          <a:p>
+            <a:pPr indent="0" marL="0">
+              <a:buNone/>
+            </a:pPr>
+            <a:r>
+              <a:rPr lang="en-US" sz="1500" dirty="0">
+                <a:solidFill>
+                  <a:srgbClr val="5B6573"/>
+                </a:solidFill>
+                <a:latin typeface="Calibri" pitchFamily="34" charset="0"/>
+                <a:ea typeface="Calibri" pitchFamily="34" charset="-122"/>
+                <a:cs typeface="Calibri" pitchFamily="34" charset="-120"/>
+              </a:rPr>
+              <a:t>students.prep: every phase, then the cleaned file</a:t>
+            </a:r>
+            <a:endParaRPr lang="en-US" sz="1500" dirty="0"/>
+          </a:p>
+        </p:txBody>
+      </p:sp>
+      <p:sp>
+        <p:nvSpPr>
+          <p:cNvPr id="12" name="Shape 10"/>
+          <p:cNvSpPr/>
+          <p:nvPr/>
+        </p:nvSpPr>
+        <p:spPr>
+          <a:xfrm>
+            <a:off x="457200" y="2523744"/>
+            <a:ext cx="384048" cy="384048"/>
+          </a:xfrm>
+          <a:prstGeom prst="ellipse">
+            <a:avLst/>
+          </a:prstGeom>
+          <a:solidFill>
+            <a:srgbClr val="E8A33D"/>
+          </a:solidFill>
+          <a:ln w="12700">
+            <a:solidFill>
+              <a:srgbClr val="E8A33D"/>
+            </a:solidFill>
+            <a:prstDash val="solid"/>
+          </a:ln>
+        </p:spPr>
+      </p:sp>
+      <p:sp>
+        <p:nvSpPr>
+          <p:cNvPr id="13" name="Text 11"/>
+          <p:cNvSpPr txBox="1"/>
+          <p:nvPr/>
+        </p:nvSpPr>
+        <p:spPr>
+          <a:xfrm>
+            <a:off x="457200" y="2523744"/>
+            <a:ext cx="384048" cy="384048"/>
+          </a:xfrm>
+          <a:prstGeom prst="rect">
+            <a:avLst/>
+          </a:prstGeom>
+          <a:noFill/>
+          <a:ln/>
+        </p:spPr>
+        <p:txBody>
+          <a:bodyPr wrap="square" lIns="0" tIns="0" rIns="0" bIns="0" rtlCol="0" anchor="ctr"/>
+          <a:lstStyle/>
+          <a:p>
+            <a:pPr algn="ctr" indent="0" marL="0">
+              <a:buNone/>
+            </a:pPr>
+            <a:r>
+              <a:rPr lang="en-US" sz="1400" b="1" dirty="0">
+                <a:solidFill>
+                  <a:srgbClr val="1B2430"/>
+                </a:solidFill>
+                <a:latin typeface="Calibri" pitchFamily="34" charset="0"/>
+                <a:ea typeface="Calibri" pitchFamily="34" charset="-122"/>
+                <a:cs typeface="Calibri" pitchFamily="34" charset="-120"/>
+              </a:rPr>
+              <a:t>3</a:t>
+            </a:r>
+            <a:endParaRPr lang="en-US" sz="1400" dirty="0"/>
+          </a:p>
+        </p:txBody>
+      </p:sp>
+      <p:sp>
+        <p:nvSpPr>
+          <p:cNvPr id="14" name="Text 12"/>
+          <p:cNvSpPr txBox="1"/>
+          <p:nvPr/>
+        </p:nvSpPr>
+        <p:spPr>
+          <a:xfrm>
+            <a:off x="1005840" y="2560320"/>
+            <a:ext cx="2194560" cy="320040"/>
+          </a:xfrm>
+          <a:prstGeom prst="rect">
+            <a:avLst/>
+          </a:prstGeom>
+          <a:noFill/>
+          <a:ln/>
+        </p:spPr>
+        <p:txBody>
+          <a:bodyPr wrap="square" lIns="0" tIns="0" rIns="0" bIns="0" rtlCol="0" anchor="ctr"/>
+          <a:lstStyle/>
+          <a:p>
+            <a:pPr indent="0" marL="0">
+              <a:buNone/>
+            </a:pPr>
+            <a:r>
+              <a:rPr lang="en-US" sz="1600" b="1" dirty="0">
+                <a:solidFill>
+                  <a:srgbClr val="1B2430"/>
+                </a:solidFill>
+                <a:latin typeface="Calibri" pitchFamily="34" charset="0"/>
+                <a:ea typeface="Calibri" pitchFamily="34" charset="-122"/>
+                <a:cs typeface="Calibri" pitchFamily="34" charset="-120"/>
+              </a:rPr>
+              <a:t>See the errors</a:t>
+            </a:r>
+            <a:endParaRPr lang="en-US" sz="1600" dirty="0"/>
+          </a:p>
+        </p:txBody>
+      </p:sp>
+      <p:sp>
+        <p:nvSpPr>
+          <p:cNvPr id="15" name="Text 13"/>
+          <p:cNvSpPr txBox="1"/>
+          <p:nvPr/>
+        </p:nvSpPr>
+        <p:spPr>
+          <a:xfrm>
+            <a:off x="3200400" y="2560320"/>
+            <a:ext cx="5486400" cy="320040"/>
+          </a:xfrm>
+          <a:prstGeom prst="rect">
+            <a:avLst/>
+          </a:prstGeom>
+          <a:noFill/>
+          <a:ln/>
+        </p:spPr>
+        <p:txBody>
+          <a:bodyPr wrap="square" lIns="0" tIns="0" rIns="0" bIns="0" rtlCol="0" anchor="ctr"/>
+          <a:lstStyle/>
+          <a:p>
+            <a:pPr indent="0" marL="0">
+              <a:buNone/>
+            </a:pPr>
+            <a:r>
+              <a:rPr lang="en-US" sz="1500" dirty="0">
+                <a:solidFill>
+                  <a:srgbClr val="5B6573"/>
+                </a:solidFill>
+                <a:latin typeface="Calibri" pitchFamily="34" charset="0"/>
+                <a:ea typeface="Calibri" pitchFamily="34" charset="-122"/>
+                <a:cs typeface="Calibri" pitchFamily="34" charset="-120"/>
+              </a:rPr>
+              <a:t>examples/errors: line, caret and hint</a:t>
+            </a:r>
+            <a:endParaRPr lang="en-US" sz="1500" dirty="0"/>
+          </a:p>
+        </p:txBody>
+      </p:sp>
+      <p:sp>
+        <p:nvSpPr>
+          <p:cNvPr id="16" name="Shape 14"/>
+          <p:cNvSpPr/>
+          <p:nvPr/>
+        </p:nvSpPr>
+        <p:spPr>
+          <a:xfrm>
+            <a:off x="457200" y="3236976"/>
+            <a:ext cx="384048" cy="384048"/>
+          </a:xfrm>
+          <a:prstGeom prst="ellipse">
+            <a:avLst/>
+          </a:prstGeom>
+          <a:solidFill>
+            <a:srgbClr val="E8A33D"/>
+          </a:solidFill>
+          <a:ln w="12700">
+            <a:solidFill>
+              <a:srgbClr val="E8A33D"/>
+            </a:solidFill>
+            <a:prstDash val="solid"/>
+          </a:ln>
+        </p:spPr>
+      </p:sp>
+      <p:sp>
+        <p:nvSpPr>
+          <p:cNvPr id="17" name="Text 15"/>
+          <p:cNvSpPr txBox="1"/>
+          <p:nvPr/>
+        </p:nvSpPr>
+        <p:spPr>
+          <a:xfrm>
+            <a:off x="457200" y="3236976"/>
+            <a:ext cx="384048" cy="384048"/>
+          </a:xfrm>
+          <a:prstGeom prst="rect">
+            <a:avLst/>
+          </a:prstGeom>
+          <a:noFill/>
+          <a:ln/>
+        </p:spPr>
+        <p:txBody>
+          <a:bodyPr wrap="square" lIns="0" tIns="0" rIns="0" bIns="0" rtlCol="0" anchor="ctr"/>
+          <a:lstStyle/>
+          <a:p>
+            <a:pPr algn="ctr" indent="0" marL="0">
+              <a:buNone/>
+            </a:pPr>
+            <a:r>
+              <a:rPr lang="en-US" sz="1400" b="1" dirty="0">
+                <a:solidFill>
+                  <a:srgbClr val="1B2430"/>
+                </a:solidFill>
+                <a:latin typeface="Calibri" pitchFamily="34" charset="0"/>
+                <a:ea typeface="Calibri" pitchFamily="34" charset="-122"/>
+                <a:cs typeface="Calibri" pitchFamily="34" charset="-120"/>
+              </a:rPr>
+              <a:t>4</a:t>
+            </a:r>
+            <a:endParaRPr lang="en-US" sz="1400" dirty="0"/>
+          </a:p>
+        </p:txBody>
+      </p:sp>
+      <p:sp>
+        <p:nvSpPr>
+          <p:cNvPr id="18" name="Text 16"/>
+          <p:cNvSpPr txBox="1"/>
+          <p:nvPr/>
+        </p:nvSpPr>
+        <p:spPr>
+          <a:xfrm>
+            <a:off x="1005840" y="3273552"/>
+            <a:ext cx="2194560" cy="320040"/>
+          </a:xfrm>
+          <a:prstGeom prst="rect">
+            <a:avLst/>
+          </a:prstGeom>
+          <a:noFill/>
+          <a:ln/>
+        </p:spPr>
+        <p:txBody>
+          <a:bodyPr wrap="square" lIns="0" tIns="0" rIns="0" bIns="0" rtlCol="0" anchor="ctr"/>
+          <a:lstStyle/>
+          <a:p>
+            <a:pPr indent="0" marL="0">
+              <a:buNone/>
+            </a:pPr>
+            <a:r>
+              <a:rPr lang="en-US" sz="1600" b="1" dirty="0">
+                <a:solidFill>
+                  <a:srgbClr val="1B2430"/>
+                </a:solidFill>
+                <a:latin typeface="Calibri" pitchFamily="34" charset="0"/>
+                <a:ea typeface="Calibri" pitchFamily="34" charset="-122"/>
+                <a:cs typeface="Calibri" pitchFamily="34" charset="-120"/>
+              </a:rPr>
+              <a:t>Certificate</a:t>
+            </a:r>
+            <a:endParaRPr lang="en-US" sz="1600" dirty="0"/>
+          </a:p>
+        </p:txBody>
+      </p:sp>
+      <p:sp>
+        <p:nvSpPr>
+          <p:cNvPr id="19" name="Text 17"/>
+          <p:cNvSpPr txBox="1"/>
+          <p:nvPr/>
+        </p:nvSpPr>
+        <p:spPr>
+          <a:xfrm>
+            <a:off x="3200400" y="3273552"/>
+            <a:ext cx="5486400" cy="320040"/>
+          </a:xfrm>
+          <a:prstGeom prst="rect">
+            <a:avLst/>
+          </a:prstGeom>
+          <a:noFill/>
+          <a:ln/>
+        </p:spPr>
+        <p:txBody>
+          <a:bodyPr wrap="square" lIns="0" tIns="0" rIns="0" bIns="0" rtlCol="0" anchor="ctr"/>
+          <a:lstStyle/>
+          <a:p>
+            <a:pPr indent="0" marL="0">
+              <a:buNone/>
+            </a:pPr>
+            <a:r>
+              <a:rPr lang="en-US" sz="1500" dirty="0">
+                <a:solidFill>
+                  <a:srgbClr val="5B6573"/>
+                </a:solidFill>
+                <a:latin typeface="Calibri" pitchFamily="34" charset="0"/>
+                <a:ea typeface="Calibri" pitchFamily="34" charset="-122"/>
+                <a:cs typeface="Calibri" pitchFamily="34" charset="-120"/>
+              </a:rPr>
+              <a:t>--certificate, then run on a new batch and a bad one</a:t>
+            </a:r>
+            <a:endParaRPr lang="en-US" sz="1500" dirty="0"/>
+          </a:p>
+        </p:txBody>
+      </p:sp>
+      <p:sp>
+        <p:nvSpPr>
+          <p:cNvPr id="20" name="Shape 18"/>
+          <p:cNvSpPr/>
+          <p:nvPr/>
+        </p:nvSpPr>
+        <p:spPr>
+          <a:xfrm>
+            <a:off x="457200" y="3950208"/>
+            <a:ext cx="384048" cy="384048"/>
+          </a:xfrm>
+          <a:prstGeom prst="ellipse">
+            <a:avLst/>
+          </a:prstGeom>
+          <a:solidFill>
+            <a:srgbClr val="E8A33D"/>
+          </a:solidFill>
+          <a:ln w="12700">
+            <a:solidFill>
+              <a:srgbClr val="E8A33D"/>
+            </a:solidFill>
+            <a:prstDash val="solid"/>
+          </a:ln>
+        </p:spPr>
+      </p:sp>
+      <p:sp>
+        <p:nvSpPr>
+          <p:cNvPr id="21" name="Text 19"/>
+          <p:cNvSpPr txBox="1"/>
+          <p:nvPr/>
+        </p:nvSpPr>
+        <p:spPr>
+          <a:xfrm>
+            <a:off x="457200" y="3950208"/>
+            <a:ext cx="384048" cy="384048"/>
+          </a:xfrm>
+          <a:prstGeom prst="rect">
+            <a:avLst/>
+          </a:prstGeom>
+          <a:noFill/>
+          <a:ln/>
+        </p:spPr>
+        <p:txBody>
+          <a:bodyPr wrap="square" lIns="0" tIns="0" rIns="0" bIns="0" rtlCol="0" anchor="ctr"/>
+          <a:lstStyle/>
+          <a:p>
+            <a:pPr algn="ctr" indent="0" marL="0">
+              <a:buNone/>
+            </a:pPr>
+            <a:r>
+              <a:rPr lang="en-US" sz="1400" b="1" dirty="0">
+                <a:solidFill>
+                  <a:srgbClr val="1B2430"/>
+                </a:solidFill>
+                <a:latin typeface="Calibri" pitchFamily="34" charset="0"/>
+                <a:ea typeface="Calibri" pitchFamily="34" charset="-122"/>
+                <a:cs typeface="Calibri" pitchFamily="34" charset="-120"/>
+              </a:rPr>
+              <a:t>5</a:t>
+            </a:r>
+            <a:endParaRPr lang="en-US" sz="1400" dirty="0"/>
+          </a:p>
+        </p:txBody>
+      </p:sp>
+      <p:sp>
+        <p:nvSpPr>
+          <p:cNvPr id="22" name="Text 20"/>
+          <p:cNvSpPr txBox="1"/>
+          <p:nvPr/>
+        </p:nvSpPr>
+        <p:spPr>
+          <a:xfrm>
+            <a:off x="1005840" y="3986784"/>
+            <a:ext cx="2194560" cy="320040"/>
+          </a:xfrm>
+          <a:prstGeom prst="rect">
+            <a:avLst/>
+          </a:prstGeom>
+          <a:noFill/>
+          <a:ln/>
+        </p:spPr>
+        <p:txBody>
+          <a:bodyPr wrap="square" lIns="0" tIns="0" rIns="0" bIns="0" rtlCol="0" anchor="ctr"/>
+          <a:lstStyle/>
+          <a:p>
+            <a:pPr indent="0" marL="0">
+              <a:buNone/>
+            </a:pPr>
+            <a:r>
+              <a:rPr lang="en-US" sz="1600" b="1" dirty="0">
+                <a:solidFill>
+                  <a:srgbClr val="1B2430"/>
+                </a:solidFill>
+                <a:latin typeface="Calibri" pitchFamily="34" charset="0"/>
+                <a:ea typeface="Calibri" pitchFamily="34" charset="-122"/>
+                <a:cs typeface="Calibri" pitchFamily="34" charset="-120"/>
+              </a:rPr>
+              <a:t>Tests</a:t>
+            </a:r>
+            <a:endParaRPr lang="en-US" sz="1600" dirty="0"/>
+          </a:p>
+        </p:txBody>
+      </p:sp>
+      <p:sp>
+        <p:nvSpPr>
+          <p:cNvPr id="23" name="Text 21"/>
+          <p:cNvSpPr txBox="1"/>
+          <p:nvPr/>
+        </p:nvSpPr>
+        <p:spPr>
+          <a:xfrm>
+            <a:off x="3200400" y="3986784"/>
+            <a:ext cx="5486400" cy="320040"/>
+          </a:xfrm>
+          <a:prstGeom prst="rect">
+            <a:avLst/>
+          </a:prstGeom>
+          <a:noFill/>
+          <a:ln/>
+        </p:spPr>
+        <p:txBody>
+          <a:bodyPr wrap="square" lIns="0" tIns="0" rIns="0" bIns="0" rtlCol="0" anchor="ctr"/>
+          <a:lstStyle/>
+          <a:p>
+            <a:pPr indent="0" marL="0">
+              <a:buNone/>
+            </a:pPr>
+            <a:r>
+              <a:rPr lang="en-US" sz="1500" dirty="0">
+                <a:solidFill>
+                  <a:srgbClr val="5B6573"/>
+                </a:solidFill>
+                <a:latin typeface="Calibri" pitchFamily="34" charset="0"/>
+                <a:ea typeface="Calibri" pitchFamily="34" charset="-122"/>
+                <a:cs typeface="Calibri" pitchFamily="34" charset="-120"/>
+              </a:rPr>
+              <a:t>run all tests: 9 programs pass</a:t>
+            </a:r>
+            <a:endParaRPr lang="en-US" sz="1500" dirty="0"/>
+          </a:p>
+        </p:txBody>
+      </p:sp>
+    </p:spTree>
+  </p:cSld>
+  <p:clrMapOvr>
+    <a:masterClrMapping/>
+  </p:clrMapOvr>
+</p:sld>
+</file>
+
+<file path=ppt/slides/slide14.xml><?xml version="1.0" encoding="utf-8"?>
+<p:sld xmlns:a="http://schemas.openxmlformats.org/drawingml/2006/main" xmlns:r="http://schemas.openxmlformats.org/officeDocument/2006/relationships" xmlns:p="http://schemas.openxmlformats.org/presentationml/2006/main">
+  <p:cSld name="Slide 14">
     <p:bg>
       <p:bgPr>
         <a:solidFill>

</xml_diff>